<commit_message>
Swap per-group Top 5 panels from CAPEX to OPEX
Per user correction: the per-cluster asset breakdown should be Top 5
OPEX, not Top 5 CAPEX. Each cluster's Top 10 CAPEX slide is unchanged;
its paired per-asset panel slide now ranks OPEX scopes (Cost
Allocation = OPEX, status 'Contar'/'TA') instead of CAPEX.
</commit_message>
<xml_diff>
--- a/PRIO_Top_CAPEX_OPEX_Despriorizados_2027.pptx
+++ b/PRIO_Top_CAPEX_OPEX_Despriorizados_2027.pptx
@@ -21178,7 +21178,7 @@
                 <a:ea typeface="Cambria" pitchFamily="34" charset="-122"/>
                 <a:cs typeface="Cambria" pitchFamily="34" charset="-120"/>
               </a:rPr>
-              <a:t>Top 5 CAPEX por Ativo · FPSO Frade</a:t>
+              <a:t>Top 5 OPEX por Ativo · FPSO Frade</a:t>
             </a:r>
             <a:endParaRPr lang="en-US" sz="2400" dirty="0"/>
           </a:p>
@@ -21217,7 +21217,7 @@
                 <a:ea typeface="Calibri" pitchFamily="34" charset="-122"/>
                 <a:cs typeface="Calibri" pitchFamily="34" charset="-120"/>
               </a:rPr>
-              <a:t>Ano 2027 · maiores escopos individuais de CAPEX, dentro de cada ativo do grupo</a:t>
+              <a:t>Ano 2027 · maiores escopos individuais de OPEX (status 'Contar' + 'TA'), dentro de cada ativo do grupo · OPEX total do grupo: US$ 26,9 mi</a:t>
             </a:r>
             <a:endParaRPr lang="en-US" sz="1250" dirty="0"/>
           </a:p>
@@ -21306,7 +21306,7 @@
                           <a:ea typeface="Calibri" pitchFamily="34" charset="-122"/>
                           <a:cs typeface="Calibri" pitchFamily="34" charset="-120"/>
                         </a:rPr>
-                        <a:t>SUBSTITUIÇÃO DOS BOOGIES DO TURRET</a:t>
+                        <a:t>Time de Hotelaria</a:t>
                       </a:r>
                       <a:endParaRPr lang="en-US" sz="1150" dirty="0">
                         <a:latin typeface="Calibri" charset="0"/>
@@ -21374,7 +21374,7 @@
                           <a:ea typeface="Calibri" pitchFamily="34" charset="-122"/>
                           <a:cs typeface="Calibri" pitchFamily="34" charset="-120"/>
                         </a:rPr>
-                        <a:t>US$ 11,4 mi</a:t>
+                        <a:t>US$ 2,3 mi</a:t>
                       </a:r>
                       <a:endParaRPr lang="en-US" sz="1150" dirty="0">
                         <a:latin typeface="Calibri" charset="0"/>
@@ -21444,7 +21444,7 @@
                           <a:ea typeface="Calibri" pitchFamily="34" charset="-122"/>
                           <a:cs typeface="Calibri" pitchFamily="34" charset="-120"/>
                         </a:rPr>
-                        <a:t>Guincho de Pull In + Reforma do Turret</a:t>
+                        <a:t>Campanha de RTI M5</a:t>
                       </a:r>
                       <a:endParaRPr lang="en-US" sz="1150" dirty="0">
                         <a:latin typeface="Calibri" charset="0"/>
@@ -21512,7 +21512,7 @@
                           <a:ea typeface="Calibri" pitchFamily="34" charset="-122"/>
                           <a:cs typeface="Calibri" pitchFamily="34" charset="-120"/>
                         </a:rPr>
-                        <a:t>US$ 8,7 mi</a:t>
+                        <a:t>US$ 2,2 mi</a:t>
                       </a:r>
                       <a:endParaRPr lang="en-US" sz="1150" dirty="0">
                         <a:latin typeface="Calibri" charset="0"/>
@@ -21582,7 +21582,7 @@
                           <a:ea typeface="Calibri" pitchFamily="34" charset="-122"/>
                           <a:cs typeface="Calibri" pitchFamily="34" charset="-120"/>
                         </a:rPr>
-                        <a:t>L3 - TURBINA</a:t>
+                        <a:t>Campanha de Preservação - Pintura</a:t>
                       </a:r>
                       <a:endParaRPr lang="en-US" sz="1150" dirty="0">
                         <a:latin typeface="Calibri" charset="0"/>
@@ -21650,7 +21650,7 @@
                           <a:ea typeface="Calibri" pitchFamily="34" charset="-122"/>
                           <a:cs typeface="Calibri" pitchFamily="34" charset="-120"/>
                         </a:rPr>
-                        <a:t>US$ 6,0 mi</a:t>
+                        <a:t>US$ 1,4 mi</a:t>
                       </a:r>
                       <a:endParaRPr lang="en-US" sz="1150" dirty="0">
                         <a:latin typeface="Calibri" charset="0"/>
@@ -21720,7 +21720,7 @@
                           <a:ea typeface="Calibri" pitchFamily="34" charset="-122"/>
                           <a:cs typeface="Calibri" pitchFamily="34" charset="-120"/>
                         </a:rPr>
-                        <a:t>Frade 100K (Fase 2)</a:t>
+                        <a:t>Reparos Definitivos - Compósito</a:t>
                       </a:r>
                       <a:endParaRPr lang="en-US" sz="1150" dirty="0">
                         <a:latin typeface="Calibri" charset="0"/>
@@ -21788,7 +21788,7 @@
                           <a:ea typeface="Calibri" pitchFamily="34" charset="-122"/>
                           <a:cs typeface="Calibri" pitchFamily="34" charset="-120"/>
                         </a:rPr>
-                        <a:t>US$ 5,4 mi</a:t>
+                        <a:t>US$ 1,3 mi</a:t>
                       </a:r>
                       <a:endParaRPr lang="en-US" sz="1150" dirty="0">
                         <a:latin typeface="Calibri" charset="0"/>
@@ -21858,7 +21858,7 @@
                           <a:ea typeface="Calibri" pitchFamily="34" charset="-122"/>
                           <a:cs typeface="Calibri" pitchFamily="34" charset="-120"/>
                         </a:rPr>
-                        <a:t>SPARE PARTS RECONDICIONAMENTO DOS BOOGIES</a:t>
+                        <a:t>Campanha de Preservação de Costado - Pintura</a:t>
                       </a:r>
                       <a:endParaRPr lang="en-US" sz="1150" dirty="0">
                         <a:latin typeface="Calibri" charset="0"/>
@@ -21926,7 +21926,7 @@
                           <a:ea typeface="Calibri" pitchFamily="34" charset="-122"/>
                           <a:cs typeface="Calibri" pitchFamily="34" charset="-120"/>
                         </a:rPr>
-                        <a:t>US$ 3,2 mi</a:t>
+                        <a:t>US$ 1,1 mi</a:t>
                       </a:r>
                       <a:endParaRPr lang="en-US" sz="1150" dirty="0">
                         <a:latin typeface="Calibri" charset="0"/>
@@ -22015,7 +22015,7 @@
                 <a:ea typeface="Calibri" pitchFamily="34" charset="-122"/>
                 <a:cs typeface="Calibri" pitchFamily="34" charset="-120"/>
               </a:rPr>
-              <a:t>Metodologia: Cost Allocation = CAPEX, status 'Contar'/'TA', agrupado por escopo dentro de cada ativo, excl. Desenvolvimento de Produção.</a:t>
+              <a:t>Metodologia: Cost Allocation = OPEX, status 'Contar'/'TA', agrupado por escopo dentro de cada ativo.</a:t>
             </a:r>
             <a:endParaRPr lang="en-US" sz="850" dirty="0"/>
           </a:p>
@@ -27039,7 +27039,7 @@
                 <a:ea typeface="Cambria" pitchFamily="34" charset="-122"/>
                 <a:cs typeface="Cambria" pitchFamily="34" charset="-120"/>
               </a:rPr>
-              <a:t>Top 5 CAPEX por Ativo · TBMT + Polvo</a:t>
+              <a:t>Top 5 OPEX por Ativo · TBMT + Polvo</a:t>
             </a:r>
             <a:endParaRPr lang="en-US" sz="2400" dirty="0"/>
           </a:p>
@@ -27078,7 +27078,7 @@
                 <a:ea typeface="Calibri" pitchFamily="34" charset="-122"/>
                 <a:cs typeface="Calibri" pitchFamily="34" charset="-120"/>
               </a:rPr>
-              <a:t>Ano 2027 · maiores escopos individuais de CAPEX, dentro de cada ativo do grupo</a:t>
+              <a:t>Ano 2027 · maiores escopos individuais de OPEX (status 'Contar' + 'TA'), dentro de cada ativo do grupo · OPEX total do grupo: US$ 32,3 mi</a:t>
             </a:r>
             <a:endParaRPr lang="en-US" sz="1250" dirty="0"/>
           </a:p>
@@ -27167,7 +27167,7 @@
                           <a:ea typeface="Calibri" pitchFamily="34" charset="-122"/>
                           <a:cs typeface="Calibri" pitchFamily="34" charset="-120"/>
                         </a:rPr>
-                        <a:t>L3 GTG B + MANUTENÇÃO GERADOR 25KH GTG B</a:t>
+                        <a:t>OPERAÇÃO USINA AGGREKO</a:t>
                       </a:r>
                       <a:endParaRPr lang="en-US" sz="1000" dirty="0">
                         <a:latin typeface="Calibri" charset="0"/>
@@ -27235,7 +27235,7 @@
                           <a:ea typeface="Calibri" pitchFamily="34" charset="-122"/>
                           <a:cs typeface="Calibri" pitchFamily="34" charset="-120"/>
                         </a:rPr>
-                        <a:t>US$ 4,8 mi</a:t>
+                        <a:t>US$ 2,0 mi</a:t>
                       </a:r>
                       <a:endParaRPr lang="en-US" sz="1000" dirty="0">
                         <a:latin typeface="Calibri" charset="0"/>
@@ -27305,7 +27305,7 @@
                           <a:ea typeface="Calibri" pitchFamily="34" charset="-122"/>
                           <a:cs typeface="Calibri" pitchFamily="34" charset="-120"/>
                         </a:rPr>
-                        <a:t>TA - Mecânica</a:t>
+                        <a:t>Baixa de Material Mecânico</a:t>
                       </a:r>
                       <a:endParaRPr lang="en-US" sz="1000" dirty="0">
                         <a:latin typeface="Calibri" charset="0"/>
@@ -27373,7 +27373,7 @@
                           <a:ea typeface="Calibri" pitchFamily="34" charset="-122"/>
                           <a:cs typeface="Calibri" pitchFamily="34" charset="-120"/>
                         </a:rPr>
-                        <a:t>US$ 1,5 mi</a:t>
+                        <a:t>US$ 1,3 mi</a:t>
                       </a:r>
                       <a:endParaRPr lang="en-US" sz="1000" dirty="0">
                         <a:latin typeface="Calibri" charset="0"/>
@@ -27443,7 +27443,7 @@
                           <a:ea typeface="Calibri" pitchFamily="34" charset="-122"/>
                           <a:cs typeface="Calibri" pitchFamily="34" charset="-120"/>
                         </a:rPr>
-                        <a:t>TA - Swivel - Pacote Hidráulico (OneSubsea)</a:t>
+                        <a:t>Mergulho - Tamponamento da caixa de mar</a:t>
                       </a:r>
                       <a:endParaRPr lang="en-US" sz="1000" dirty="0">
                         <a:latin typeface="Calibri" charset="0"/>
@@ -27511,7 +27511,7 @@
                           <a:ea typeface="Calibri" pitchFamily="34" charset="-122"/>
                           <a:cs typeface="Calibri" pitchFamily="34" charset="-120"/>
                         </a:rPr>
-                        <a:t>US$ 1,4 mi</a:t>
+                        <a:t>US$ 1,2 mi</a:t>
                       </a:r>
                       <a:endParaRPr lang="en-US" sz="1000" dirty="0">
                         <a:latin typeface="Calibri" charset="0"/>
@@ -27581,7 +27581,7 @@
                           <a:ea typeface="Calibri" pitchFamily="34" charset="-122"/>
                           <a:cs typeface="Calibri" pitchFamily="34" charset="-120"/>
                         </a:rPr>
-                        <a:t>TA - Elétrica</a:t>
+                        <a:t>M5 - Time de Construção - Instalações (Fabric, Constr e Mont.)</a:t>
                       </a:r>
                       <a:endParaRPr lang="en-US" sz="1000" dirty="0">
                         <a:latin typeface="Calibri" charset="0"/>
@@ -27649,7 +27649,7 @@
                           <a:ea typeface="Calibri" pitchFamily="34" charset="-122"/>
                           <a:cs typeface="Calibri" pitchFamily="34" charset="-120"/>
                         </a:rPr>
-                        <a:t>US$ 982,4 mil</a:t>
+                        <a:t>US$ 1,1 mi</a:t>
                       </a:r>
                       <a:endParaRPr lang="en-US" sz="1000" dirty="0">
                         <a:latin typeface="Calibri" charset="0"/>
@@ -27719,7 +27719,7 @@
                           <a:ea typeface="Calibri" pitchFamily="34" charset="-122"/>
                           <a:cs typeface="Calibri" pitchFamily="34" charset="-120"/>
                         </a:rPr>
-                        <a:t>TA - Caldeiraria</a:t>
+                        <a:t>Sistema de Dilúvio (FW e FF) - Troca de Tubulações</a:t>
                       </a:r>
                       <a:endParaRPr lang="en-US" sz="1000" dirty="0">
                         <a:latin typeface="Calibri" charset="0"/>
@@ -27787,7 +27787,7 @@
                           <a:ea typeface="Calibri" pitchFamily="34" charset="-122"/>
                           <a:cs typeface="Calibri" pitchFamily="34" charset="-120"/>
                         </a:rPr>
-                        <a:t>US$ 816,1 mil</a:t>
+                        <a:t>US$ 1,1 mi</a:t>
                       </a:r>
                       <a:endParaRPr lang="en-US" sz="1000" dirty="0">
                         <a:latin typeface="Calibri" charset="0"/>
@@ -27926,7 +27926,7 @@
                           <a:ea typeface="Calibri" pitchFamily="34" charset="-122"/>
                           <a:cs typeface="Calibri" pitchFamily="34" charset="-120"/>
                         </a:rPr>
-                        <a:t>Retrofit do Motor - Bomba de Incêndio</a:t>
+                        <a:t>Baixa de Material Mecânico</a:t>
                       </a:r>
                       <a:endParaRPr lang="en-US" sz="1000" dirty="0">
                         <a:latin typeface="Calibri" charset="0"/>
@@ -27994,7 +27994,7 @@
                           <a:ea typeface="Calibri" pitchFamily="34" charset="-122"/>
                           <a:cs typeface="Calibri" pitchFamily="34" charset="-120"/>
                         </a:rPr>
-                        <a:t>US$ 863,1 mil</a:t>
+                        <a:t>US$ 960,0 mil</a:t>
                       </a:r>
                       <a:endParaRPr lang="en-US" sz="1000" dirty="0">
                         <a:latin typeface="Calibri" charset="0"/>
@@ -28064,7 +28064,7 @@
                           <a:ea typeface="Calibri" pitchFamily="34" charset="-122"/>
                           <a:cs typeface="Calibri" pitchFamily="34" charset="-120"/>
                         </a:rPr>
-                        <a:t>Revitalização do compressor de Ar de Instrumento</a:t>
+                        <a:t>Baixa de material Automação</a:t>
                       </a:r>
                       <a:endParaRPr lang="en-US" sz="1000" dirty="0">
                         <a:latin typeface="Calibri" charset="0"/>
@@ -28132,7 +28132,7 @@
                           <a:ea typeface="Calibri" pitchFamily="34" charset="-122"/>
                           <a:cs typeface="Calibri" pitchFamily="34" charset="-120"/>
                         </a:rPr>
-                        <a:t>US$ 544,8 mil</a:t>
+                        <a:t>US$ 628,8 mil</a:t>
                       </a:r>
                       <a:endParaRPr lang="en-US" sz="1000" dirty="0">
                         <a:latin typeface="Calibri" charset="0"/>
@@ -28202,7 +28202,7 @@
                           <a:ea typeface="Calibri" pitchFamily="34" charset="-122"/>
                           <a:cs typeface="Calibri" pitchFamily="34" charset="-120"/>
                         </a:rPr>
-                        <a:t>TA - Compra de Placas de controle dos VFDs Rockwell</a:t>
+                        <a:t>M5 - Time de Construção - Instalações (Fabric, Constr e Mont.)</a:t>
                       </a:r>
                       <a:endParaRPr lang="en-US" sz="1000" dirty="0">
                         <a:latin typeface="Calibri" charset="0"/>
@@ -28270,7 +28270,7 @@
                           <a:ea typeface="Calibri" pitchFamily="34" charset="-122"/>
                           <a:cs typeface="Calibri" pitchFamily="34" charset="-120"/>
                         </a:rPr>
-                        <a:t>US$ 526,1 mil</a:t>
+                        <a:t>US$ 610,0 mil</a:t>
                       </a:r>
                       <a:endParaRPr lang="en-US" sz="1000" dirty="0">
                         <a:latin typeface="Calibri" charset="0"/>
@@ -28340,7 +28340,7 @@
                           <a:ea typeface="Calibri" pitchFamily="34" charset="-122"/>
                           <a:cs typeface="Calibri" pitchFamily="34" charset="-120"/>
                         </a:rPr>
-                        <a:t>MPP - Adequação do sistema de Selagem Multifásica</a:t>
+                        <a:t>Apoio à Manutenção - Time de Construção - Instalações</a:t>
                       </a:r>
                       <a:endParaRPr lang="en-US" sz="1000" dirty="0">
                         <a:latin typeface="Calibri" charset="0"/>
@@ -28408,7 +28408,7 @@
                           <a:ea typeface="Calibri" pitchFamily="34" charset="-122"/>
                           <a:cs typeface="Calibri" pitchFamily="34" charset="-120"/>
                         </a:rPr>
-                        <a:t>US$ 519,2 mil</a:t>
+                        <a:t>US$ 600,0 mil</a:t>
                       </a:r>
                       <a:endParaRPr lang="en-US" sz="1000" dirty="0">
                         <a:latin typeface="Calibri" charset="0"/>
@@ -28478,7 +28478,7 @@
                           <a:ea typeface="Calibri" pitchFamily="34" charset="-122"/>
                           <a:cs typeface="Calibri" pitchFamily="34" charset="-120"/>
                         </a:rPr>
-                        <a:t>TA - Caldeiraria</a:t>
+                        <a:t>Campanha de normatização de DTPs - WHP Polvo-A</a:t>
                       </a:r>
                       <a:endParaRPr lang="en-US" sz="1000" dirty="0">
                         <a:latin typeface="Calibri" charset="0"/>
@@ -28546,7 +28546,7 @@
                           <a:ea typeface="Calibri" pitchFamily="34" charset="-122"/>
                           <a:cs typeface="Calibri" pitchFamily="34" charset="-120"/>
                         </a:rPr>
-                        <a:t>US$ 484,9 mil</a:t>
+                        <a:t>US$ 419,8 mil</a:t>
                       </a:r>
                       <a:endParaRPr lang="en-US" sz="1000" dirty="0">
                         <a:latin typeface="Calibri" charset="0"/>
@@ -28635,7 +28635,7 @@
                 <a:ea typeface="Calibri" pitchFamily="34" charset="-122"/>
                 <a:cs typeface="Calibri" pitchFamily="34" charset="-120"/>
               </a:rPr>
-              <a:t>Metodologia: Cost Allocation = CAPEX, status 'Contar'/'TA', agrupado por escopo dentro de cada ativo, excl. Desenvolvimento de Produção.</a:t>
+              <a:t>Metodologia: Cost Allocation = OPEX, status 'Contar'/'TA', agrupado por escopo dentro de cada ativo.</a:t>
             </a:r>
             <a:endParaRPr lang="en-US" sz="850" dirty="0"/>
           </a:p>
@@ -33659,7 +33659,7 @@
                 <a:ea typeface="Cambria" pitchFamily="34" charset="-122"/>
                 <a:cs typeface="Cambria" pitchFamily="34" charset="-120"/>
               </a:rPr>
-              <a:t>Top 5 CAPEX por Ativo · Peregrino</a:t>
+              <a:t>Top 5 OPEX por Ativo · Peregrino</a:t>
             </a:r>
             <a:endParaRPr lang="en-US" sz="2400" dirty="0"/>
           </a:p>
@@ -33698,7 +33698,7 @@
                 <a:ea typeface="Calibri" pitchFamily="34" charset="-122"/>
                 <a:cs typeface="Calibri" pitchFamily="34" charset="-120"/>
               </a:rPr>
-              <a:t>Ano 2027 · maiores escopos individuais de CAPEX, dentro de cada ativo do grupo</a:t>
+              <a:t>Ano 2027 · maiores escopos individuais de OPEX (status 'Contar' + 'TA'), dentro de cada ativo do grupo · OPEX total do grupo: US$ 96,7 mi</a:t>
             </a:r>
             <a:endParaRPr lang="en-US" sz="1250" dirty="0"/>
           </a:p>
@@ -33787,7 +33787,7 @@
                           <a:ea typeface="Calibri" pitchFamily="34" charset="-122"/>
                           <a:cs typeface="Calibri" pitchFamily="34" charset="-120"/>
                         </a:rPr>
-                        <a:t>Atualização PLC das Turbinas</a:t>
+                        <a:t>Fixo - PRIO + OSM</a:t>
                       </a:r>
                       <a:endParaRPr lang="en-US" sz="1000" dirty="0">
                         <a:latin typeface="Calibri" charset="0"/>
@@ -33855,7 +33855,7 @@
                           <a:ea typeface="Calibri" pitchFamily="34" charset="-122"/>
                           <a:cs typeface="Calibri" pitchFamily="34" charset="-120"/>
                         </a:rPr>
-                        <a:t>US$ 3,1 mi</a:t>
+                        <a:t>US$ 19,6 mi</a:t>
                       </a:r>
                       <a:endParaRPr lang="en-US" sz="1000" dirty="0">
                         <a:latin typeface="Calibri" charset="0"/>
@@ -33925,7 +33925,7 @@
                           <a:ea typeface="Calibri" pitchFamily="34" charset="-122"/>
                           <a:cs typeface="Calibri" pitchFamily="34" charset="-120"/>
                         </a:rPr>
-                        <a:t>Substituição de Internos do Coalescer (TAR)</a:t>
+                        <a:t>Time de Construção - Pintura</a:t>
                       </a:r>
                       <a:endParaRPr lang="en-US" sz="1000" dirty="0">
                         <a:latin typeface="Calibri" charset="0"/>
@@ -33993,7 +33993,7 @@
                           <a:ea typeface="Calibri" pitchFamily="34" charset="-122"/>
                           <a:cs typeface="Calibri" pitchFamily="34" charset="-120"/>
                         </a:rPr>
-                        <a:t>US$ 2,0 mi</a:t>
+                        <a:t>US$ 6,5 mi</a:t>
                       </a:r>
                       <a:endParaRPr lang="en-US" sz="1000" dirty="0">
                         <a:latin typeface="Calibri" charset="0"/>
@@ -34063,7 +34063,7 @@
                           <a:ea typeface="Calibri" pitchFamily="34" charset="-122"/>
                           <a:cs typeface="Calibri" pitchFamily="34" charset="-120"/>
                         </a:rPr>
-                        <a:t>Troca da Membrana do Sistema de Geração de Nitrogênio Alpha e Bravo</a:t>
+                        <a:t>Time de Construção - Instalações (Fabric, Constr e Mont.)</a:t>
                       </a:r>
                       <a:endParaRPr lang="en-US" sz="1000" dirty="0">
                         <a:latin typeface="Calibri" charset="0"/>
@@ -34131,7 +34131,7 @@
                           <a:ea typeface="Calibri" pitchFamily="34" charset="-122"/>
                           <a:cs typeface="Calibri" pitchFamily="34" charset="-120"/>
                         </a:rPr>
-                        <a:t>US$ 1,3 mi</a:t>
+                        <a:t>US$ 2,0 mi</a:t>
                       </a:r>
                       <a:endParaRPr lang="en-US" sz="1000" dirty="0">
                         <a:latin typeface="Calibri" charset="0"/>
@@ -34201,7 +34201,7 @@
                           <a:ea typeface="Calibri" pitchFamily="34" charset="-122"/>
                           <a:cs typeface="Calibri" pitchFamily="34" charset="-120"/>
                         </a:rPr>
-                        <a:t>Overhaul da Bomba Framo (SWLP) - B</a:t>
+                        <a:t>Catering</a:t>
                       </a:r>
                       <a:endParaRPr lang="en-US" sz="1000" dirty="0">
                         <a:latin typeface="Calibri" charset="0"/>
@@ -34269,7 +34269,7 @@
                           <a:ea typeface="Calibri" pitchFamily="34" charset="-122"/>
                           <a:cs typeface="Calibri" pitchFamily="34" charset="-120"/>
                         </a:rPr>
-                        <a:t>US$ 1,3 mi</a:t>
+                        <a:t>US$ 1,9 mi</a:t>
                       </a:r>
                       <a:endParaRPr lang="en-US" sz="1000" dirty="0">
                         <a:latin typeface="Calibri" charset="0"/>
@@ -34339,7 +34339,7 @@
                           <a:ea typeface="Calibri" pitchFamily="34" charset="-122"/>
                           <a:cs typeface="Calibri" pitchFamily="34" charset="-120"/>
                         </a:rPr>
-                        <a:t>Desmobilização - TA</a:t>
+                        <a:t>Tratamento e Descarte de Água do Slop</a:t>
                       </a:r>
                       <a:endParaRPr lang="en-US" sz="1000" dirty="0">
                         <a:latin typeface="Calibri" charset="0"/>
@@ -34407,7 +34407,7 @@
                           <a:ea typeface="Calibri" pitchFamily="34" charset="-122"/>
                           <a:cs typeface="Calibri" pitchFamily="34" charset="-120"/>
                         </a:rPr>
-                        <a:t>US$ 1,0 mi</a:t>
+                        <a:t>US$ 1,7 mi</a:t>
                       </a:r>
                       <a:endParaRPr lang="en-US" sz="1000" dirty="0">
                         <a:latin typeface="Calibri" charset="0"/>
@@ -34546,7 +34546,7 @@
                           <a:ea typeface="Calibri" pitchFamily="34" charset="-122"/>
                           <a:cs typeface="Calibri" pitchFamily="34" charset="-120"/>
                         </a:rPr>
-                        <a:t>Troca da lança do Guindaste Oeste</a:t>
+                        <a:t>Fixo - PRIO + OSM</a:t>
                       </a:r>
                       <a:endParaRPr lang="en-US" sz="1000" dirty="0">
                         <a:latin typeface="Calibri" charset="0"/>
@@ -34614,7 +34614,7 @@
                           <a:ea typeface="Calibri" pitchFamily="34" charset="-122"/>
                           <a:cs typeface="Calibri" pitchFamily="34" charset="-120"/>
                         </a:rPr>
-                        <a:t>US$ 3,5 mi</a:t>
+                        <a:t>US$ 6,7 mi</a:t>
                       </a:r>
                       <a:endParaRPr lang="en-US" sz="1000" dirty="0">
                         <a:latin typeface="Calibri" charset="0"/>
@@ -34684,7 +34684,7 @@
                           <a:ea typeface="Calibri" pitchFamily="34" charset="-122"/>
                           <a:cs typeface="Calibri" pitchFamily="34" charset="-120"/>
                         </a:rPr>
-                        <a:t>Upgrade de obsolescência do INSUM</a:t>
+                        <a:t>Catering</a:t>
                       </a:r>
                       <a:endParaRPr lang="en-US" sz="1000" dirty="0">
                         <a:latin typeface="Calibri" charset="0"/>
@@ -34752,7 +34752,7 @@
                           <a:ea typeface="Calibri" pitchFamily="34" charset="-122"/>
                           <a:cs typeface="Calibri" pitchFamily="34" charset="-120"/>
                         </a:rPr>
-                        <a:t>US$ 2,0 mi</a:t>
+                        <a:t>US$ 1,6 mi</a:t>
                       </a:r>
                       <a:endParaRPr lang="en-US" sz="1000" dirty="0">
                         <a:latin typeface="Calibri" charset="0"/>
@@ -34822,7 +34822,7 @@
                           <a:ea typeface="Calibri" pitchFamily="34" charset="-122"/>
                           <a:cs typeface="Calibri" pitchFamily="34" charset="-120"/>
                         </a:rPr>
-                        <a:t>Desmobilização TA</a:t>
+                        <a:t>Time de Construção - Instalações (Fabric, Constr e Mont.)</a:t>
                       </a:r>
                       <a:endParaRPr lang="en-US" sz="1000" dirty="0">
                         <a:latin typeface="Calibri" charset="0"/>
@@ -34890,7 +34890,7 @@
                           <a:ea typeface="Calibri" pitchFamily="34" charset="-122"/>
                           <a:cs typeface="Calibri" pitchFamily="34" charset="-120"/>
                         </a:rPr>
-                        <a:t>US$ 684,3 mil</a:t>
+                        <a:t>US$ 1,5 mi</a:t>
                       </a:r>
                       <a:endParaRPr lang="en-US" sz="1000" dirty="0">
                         <a:latin typeface="Calibri" charset="0"/>
@@ -34960,7 +34960,7 @@
                           <a:ea typeface="Calibri" pitchFamily="34" charset="-122"/>
                           <a:cs typeface="Calibri" pitchFamily="34" charset="-120"/>
                         </a:rPr>
-                        <a:t>Mobilização TA</a:t>
+                        <a:t>Plano de Gerenciamento de Corrosão</a:t>
                       </a:r>
                       <a:endParaRPr lang="en-US" sz="1000" dirty="0">
                         <a:latin typeface="Calibri" charset="0"/>
@@ -35028,7 +35028,7 @@
                           <a:ea typeface="Calibri" pitchFamily="34" charset="-122"/>
                           <a:cs typeface="Calibri" pitchFamily="34" charset="-120"/>
                         </a:rPr>
-                        <a:t>US$ 684,3 mil</a:t>
+                        <a:t>US$ 976,2 mil</a:t>
                       </a:r>
                       <a:endParaRPr lang="en-US" sz="1000" dirty="0">
                         <a:latin typeface="Calibri" charset="0"/>
@@ -35098,7 +35098,7 @@
                           <a:ea typeface="Calibri" pitchFamily="34" charset="-122"/>
                           <a:cs typeface="Calibri" pitchFamily="34" charset="-120"/>
                         </a:rPr>
-                        <a:t>Instalação Detectores H2S</a:t>
+                        <a:t>Inspeção Jackets</a:t>
                       </a:r>
                       <a:endParaRPr lang="en-US" sz="1000" dirty="0">
                         <a:latin typeface="Calibri" charset="0"/>
@@ -35166,7 +35166,7 @@
                           <a:ea typeface="Calibri" pitchFamily="34" charset="-122"/>
                           <a:cs typeface="Calibri" pitchFamily="34" charset="-120"/>
                         </a:rPr>
-                        <a:t>US$ 603,5 mil</a:t>
+                        <a:t>US$ 400,0 mil</a:t>
                       </a:r>
                       <a:endParaRPr lang="en-US" sz="1000" dirty="0">
                         <a:latin typeface="Calibri" charset="0"/>
@@ -35305,7 +35305,7 @@
                           <a:ea typeface="Calibri" pitchFamily="34" charset="-122"/>
                           <a:cs typeface="Calibri" pitchFamily="34" charset="-120"/>
                         </a:rPr>
-                        <a:t>Upgrade de obsolescência do INSUM</a:t>
+                        <a:t>TIME FIXO PRIO</a:t>
                       </a:r>
                       <a:endParaRPr lang="en-US" sz="1000" dirty="0">
                         <a:latin typeface="Calibri" charset="0"/>
@@ -35373,7 +35373,7 @@
                           <a:ea typeface="Calibri" pitchFamily="34" charset="-122"/>
                           <a:cs typeface="Calibri" pitchFamily="34" charset="-120"/>
                         </a:rPr>
-                        <a:t>US$ 2,0 mi</a:t>
+                        <a:t>US$ 4,8 mi</a:t>
                       </a:r>
                       <a:endParaRPr lang="en-US" sz="1000" dirty="0">
                         <a:latin typeface="Calibri" charset="0"/>
@@ -35443,7 +35443,7 @@
                           <a:ea typeface="Calibri" pitchFamily="34" charset="-122"/>
                           <a:cs typeface="Calibri" pitchFamily="34" charset="-120"/>
                         </a:rPr>
-                        <a:t>Instalação detectores H2S</a:t>
+                        <a:t>Time de Construção - Instalações (Fabric, Constr, Mont e RTI.)</a:t>
                       </a:r>
                       <a:endParaRPr lang="en-US" sz="1000" dirty="0">
                         <a:latin typeface="Calibri" charset="0"/>
@@ -35511,7 +35511,7 @@
                           <a:ea typeface="Calibri" pitchFamily="34" charset="-122"/>
                           <a:cs typeface="Calibri" pitchFamily="34" charset="-120"/>
                         </a:rPr>
-                        <a:t>US$ 603,5 mil</a:t>
+                        <a:t>US$ 2,1 mi</a:t>
                       </a:r>
                       <a:endParaRPr lang="en-US" sz="1000" dirty="0">
                         <a:latin typeface="Calibri" charset="0"/>
@@ -35581,7 +35581,7 @@
                           <a:ea typeface="Calibri" pitchFamily="34" charset="-122"/>
                           <a:cs typeface="Calibri" pitchFamily="34" charset="-120"/>
                         </a:rPr>
-                        <a:t>Desmobilização TA</a:t>
+                        <a:t>TIME FIXO OSM</a:t>
                       </a:r>
                       <a:endParaRPr lang="en-US" sz="1000" dirty="0">
                         <a:latin typeface="Calibri" charset="0"/>
@@ -35649,7 +35649,7 @@
                           <a:ea typeface="Calibri" pitchFamily="34" charset="-122"/>
                           <a:cs typeface="Calibri" pitchFamily="34" charset="-120"/>
                         </a:rPr>
-                        <a:t>US$ 567,3 mil</a:t>
+                        <a:t>US$ 1,9 mi</a:t>
                       </a:r>
                       <a:endParaRPr lang="en-US" sz="1000" dirty="0">
                         <a:latin typeface="Calibri" charset="0"/>
@@ -35719,7 +35719,7 @@
                           <a:ea typeface="Calibri" pitchFamily="34" charset="-122"/>
                           <a:cs typeface="Calibri" pitchFamily="34" charset="-120"/>
                         </a:rPr>
-                        <a:t>Mobilização TA</a:t>
+                        <a:t>TIME FIXO SODEXO</a:t>
                       </a:r>
                       <a:endParaRPr lang="en-US" sz="1000" dirty="0">
                         <a:latin typeface="Calibri" charset="0"/>
@@ -35787,7 +35787,7 @@
                           <a:ea typeface="Calibri" pitchFamily="34" charset="-122"/>
                           <a:cs typeface="Calibri" pitchFamily="34" charset="-120"/>
                         </a:rPr>
-                        <a:t>US$ 567,3 mil</a:t>
+                        <a:t>US$ 1,6 mi</a:t>
                       </a:r>
                       <a:endParaRPr lang="en-US" sz="1000" dirty="0">
                         <a:latin typeface="Calibri" charset="0"/>
@@ -35857,7 +35857,7 @@
                           <a:ea typeface="Calibri" pitchFamily="34" charset="-122"/>
                           <a:cs typeface="Calibri" pitchFamily="34" charset="-120"/>
                         </a:rPr>
-                        <a:t>Instalação de nova unidade de Osmose Reversa</a:t>
+                        <a:t>Plano de Gerenciamento de Corrosão</a:t>
                       </a:r>
                       <a:endParaRPr lang="en-US" sz="1000" dirty="0">
                         <a:latin typeface="Calibri" charset="0"/>
@@ -35925,7 +35925,7 @@
                           <a:ea typeface="Calibri" pitchFamily="34" charset="-122"/>
                           <a:cs typeface="Calibri" pitchFamily="34" charset="-120"/>
                         </a:rPr>
-                        <a:t>US$ 509,4 mil</a:t>
+                        <a:t>US$ 1,3 mi</a:t>
                       </a:r>
                       <a:endParaRPr lang="en-US" sz="1000" dirty="0">
                         <a:latin typeface="Calibri" charset="0"/>
@@ -36064,7 +36064,7 @@
                           <a:ea typeface="Calibri" pitchFamily="34" charset="-122"/>
                           <a:cs typeface="Calibri" pitchFamily="34" charset="-120"/>
                         </a:rPr>
-                        <a:t>Isolamento Térmico e Heat Tracing — Linha de FG (WHP-C)</a:t>
+                        <a:t>TIME FIXO PRIO</a:t>
                       </a:r>
                       <a:endParaRPr lang="en-US" sz="1000" dirty="0">
                         <a:latin typeface="Calibri" charset="0"/>
@@ -36132,7 +36132,7 @@
                           <a:ea typeface="Calibri" pitchFamily="34" charset="-122"/>
                           <a:cs typeface="Calibri" pitchFamily="34" charset="-120"/>
                         </a:rPr>
-                        <a:t>US$ 707,6 mil</a:t>
+                        <a:t>US$ 5,6 mi</a:t>
                       </a:r>
                       <a:endParaRPr lang="en-US" sz="1000" dirty="0">
                         <a:latin typeface="Calibri" charset="0"/>
@@ -36202,7 +36202,7 @@
                           <a:ea typeface="Calibri" pitchFamily="34" charset="-122"/>
                           <a:cs typeface="Calibri" pitchFamily="34" charset="-120"/>
                         </a:rPr>
-                        <a:t>Instalação detectores H2S</a:t>
+                        <a:t>Time de Construção - Instalações (Fabric, Constr e Mont.)</a:t>
                       </a:r>
                       <a:endParaRPr lang="en-US" sz="1000" dirty="0">
                         <a:latin typeface="Calibri" charset="0"/>
@@ -36270,7 +36270,7 @@
                           <a:ea typeface="Calibri" pitchFamily="34" charset="-122"/>
                           <a:cs typeface="Calibri" pitchFamily="34" charset="-120"/>
                         </a:rPr>
-                        <a:t>US$ 603,5 mil</a:t>
+                        <a:t>US$ 3,3 mi</a:t>
                       </a:r>
                       <a:endParaRPr lang="en-US" sz="1000" dirty="0">
                         <a:latin typeface="Calibri" charset="0"/>
@@ -36340,7 +36340,7 @@
                           <a:ea typeface="Calibri" pitchFamily="34" charset="-122"/>
                           <a:cs typeface="Calibri" pitchFamily="34" charset="-120"/>
                         </a:rPr>
-                        <a:t>Desmobilização TA</a:t>
+                        <a:t>TIME FIXO OSM</a:t>
                       </a:r>
                       <a:endParaRPr lang="en-US" sz="1000" dirty="0">
                         <a:latin typeface="Calibri" charset="0"/>
@@ -36408,7 +36408,7 @@
                           <a:ea typeface="Calibri" pitchFamily="34" charset="-122"/>
                           <a:cs typeface="Calibri" pitchFamily="34" charset="-120"/>
                         </a:rPr>
-                        <a:t>US$ 562,5 mil</a:t>
+                        <a:t>US$ 2,2 mi</a:t>
                       </a:r>
                       <a:endParaRPr lang="en-US" sz="1000" dirty="0">
                         <a:latin typeface="Calibri" charset="0"/>
@@ -36478,7 +36478,7 @@
                           <a:ea typeface="Calibri" pitchFamily="34" charset="-122"/>
                           <a:cs typeface="Calibri" pitchFamily="34" charset="-120"/>
                         </a:rPr>
-                        <a:t>Mobilização TA</a:t>
+                        <a:t>TIME FIXO SODEXO</a:t>
                       </a:r>
                       <a:endParaRPr lang="en-US" sz="1000" dirty="0">
                         <a:latin typeface="Calibri" charset="0"/>
@@ -36546,7 +36546,7 @@
                           <a:ea typeface="Calibri" pitchFamily="34" charset="-122"/>
                           <a:cs typeface="Calibri" pitchFamily="34" charset="-120"/>
                         </a:rPr>
-                        <a:t>US$ 562,5 mil</a:t>
+                        <a:t>US$ 2,1 mi</a:t>
                       </a:r>
                       <a:endParaRPr lang="en-US" sz="1000" dirty="0">
                         <a:latin typeface="Calibri" charset="0"/>
@@ -36616,7 +36616,7 @@
                           <a:ea typeface="Calibri" pitchFamily="34" charset="-122"/>
                           <a:cs typeface="Calibri" pitchFamily="34" charset="-120"/>
                         </a:rPr>
-                        <a:t>Upgrade CCTV</a:t>
+                        <a:t>Manutenção Preventiva (L1) da GTG-A</a:t>
                       </a:r>
                       <a:endParaRPr lang="en-US" sz="1000" dirty="0">
                         <a:latin typeface="Calibri" charset="0"/>
@@ -36684,7 +36684,7 @@
                           <a:ea typeface="Calibri" pitchFamily="34" charset="-122"/>
                           <a:cs typeface="Calibri" pitchFamily="34" charset="-120"/>
                         </a:rPr>
-                        <a:t>US$ 465,4 mil</a:t>
+                        <a:t>US$ 708,5 mil</a:t>
                       </a:r>
                       <a:endParaRPr lang="en-US" sz="1000" dirty="0">
                         <a:latin typeface="Calibri" charset="0"/>
@@ -36773,7 +36773,7 @@
                 <a:ea typeface="Calibri" pitchFamily="34" charset="-122"/>
                 <a:cs typeface="Calibri" pitchFamily="34" charset="-120"/>
               </a:rPr>
-              <a:t>Metodologia: Cost Allocation = CAPEX, status 'Contar'/'TA', agrupado por escopo dentro de cada ativo, excl. Desenvolvimento de Produção.</a:t>
+              <a:t>Metodologia: Cost Allocation = OPEX, status 'Contar'/'TA', agrupado por escopo dentro de cada ativo.</a:t>
             </a:r>
             <a:endParaRPr lang="en-US" sz="850" dirty="0"/>
           </a:p>

</xml_diff>

<commit_message>
Apply requesting-area priority filter to per-group Top 5 OPEX panels
The per-cluster Top 5 OPEX por Ativo panels now use the same area
priority filter already applied to the standalone Top 10 OPEX slide
(Manutenção, Suporte Técnico, Confiabilidade, Integridade, Naval,
Construção, Projetos), instead of an unrestricted top 5 by value.
</commit_message>
<xml_diff>
--- a/PRIO_Top_CAPEX_OPEX_Despriorizados_2027.pptx
+++ b/PRIO_Top_CAPEX_OPEX_Despriorizados_2027.pptx
@@ -21217,7 +21217,7 @@
                 <a:ea typeface="Calibri" pitchFamily="34" charset="-122"/>
                 <a:cs typeface="Calibri" pitchFamily="34" charset="-120"/>
               </a:rPr>
-              <a:t>Ano 2027 · maiores escopos individuais de OPEX (status 'Contar' + 'TA'), dentro de cada ativo do grupo · OPEX total do grupo: US$ 26,9 mi</a:t>
+              <a:t>Ano 2027 · maiores escopos de OPEX nas áreas priorizadas (Manutenção, Suporte Técnico, Confiabilidade, Integridade, Naval, Construção, Projetos) · total nessas áreas: US$ 19,4 mi</a:t>
             </a:r>
             <a:endParaRPr lang="en-US" sz="1250" dirty="0"/>
           </a:p>
@@ -21306,7 +21306,7 @@
                           <a:ea typeface="Calibri" pitchFamily="34" charset="-122"/>
                           <a:cs typeface="Calibri" pitchFamily="34" charset="-120"/>
                         </a:rPr>
-                        <a:t>Time de Hotelaria</a:t>
+                        <a:t>Campanha de RTI M5</a:t>
                       </a:r>
                       <a:endParaRPr lang="en-US" sz="1150" dirty="0">
                         <a:latin typeface="Calibri" charset="0"/>
@@ -21374,7 +21374,7 @@
                           <a:ea typeface="Calibri" pitchFamily="34" charset="-122"/>
                           <a:cs typeface="Calibri" pitchFamily="34" charset="-120"/>
                         </a:rPr>
-                        <a:t>US$ 2,3 mi</a:t>
+                        <a:t>US$ 2,2 mi</a:t>
                       </a:r>
                       <a:endParaRPr lang="en-US" sz="1150" dirty="0">
                         <a:latin typeface="Calibri" charset="0"/>
@@ -21444,7 +21444,7 @@
                           <a:ea typeface="Calibri" pitchFamily="34" charset="-122"/>
                           <a:cs typeface="Calibri" pitchFamily="34" charset="-120"/>
                         </a:rPr>
-                        <a:t>Campanha de RTI M5</a:t>
+                        <a:t>Campanha de Preservação - Pintura</a:t>
                       </a:r>
                       <a:endParaRPr lang="en-US" sz="1150" dirty="0">
                         <a:latin typeface="Calibri" charset="0"/>
@@ -21512,7 +21512,7 @@
                           <a:ea typeface="Calibri" pitchFamily="34" charset="-122"/>
                           <a:cs typeface="Calibri" pitchFamily="34" charset="-120"/>
                         </a:rPr>
-                        <a:t>US$ 2,2 mi</a:t>
+                        <a:t>US$ 1,4 mi</a:t>
                       </a:r>
                       <a:endParaRPr lang="en-US" sz="1150" dirty="0">
                         <a:latin typeface="Calibri" charset="0"/>
@@ -21582,7 +21582,7 @@
                           <a:ea typeface="Calibri" pitchFamily="34" charset="-122"/>
                           <a:cs typeface="Calibri" pitchFamily="34" charset="-120"/>
                         </a:rPr>
-                        <a:t>Campanha de Preservação - Pintura</a:t>
+                        <a:t>Reparos Definitivos - Compósito</a:t>
                       </a:r>
                       <a:endParaRPr lang="en-US" sz="1150" dirty="0">
                         <a:latin typeface="Calibri" charset="0"/>
@@ -21650,7 +21650,7 @@
                           <a:ea typeface="Calibri" pitchFamily="34" charset="-122"/>
                           <a:cs typeface="Calibri" pitchFamily="34" charset="-120"/>
                         </a:rPr>
-                        <a:t>US$ 1,4 mi</a:t>
+                        <a:t>US$ 1,3 mi</a:t>
                       </a:r>
                       <a:endParaRPr lang="en-US" sz="1150" dirty="0">
                         <a:latin typeface="Calibri" charset="0"/>
@@ -21720,7 +21720,7 @@
                           <a:ea typeface="Calibri" pitchFamily="34" charset="-122"/>
                           <a:cs typeface="Calibri" pitchFamily="34" charset="-120"/>
                         </a:rPr>
-                        <a:t>Reparos Definitivos - Compósito</a:t>
+                        <a:t>Campanha de Preservação de Costado - Pintura</a:t>
                       </a:r>
                       <a:endParaRPr lang="en-US" sz="1150" dirty="0">
                         <a:latin typeface="Calibri" charset="0"/>
@@ -21788,7 +21788,7 @@
                           <a:ea typeface="Calibri" pitchFamily="34" charset="-122"/>
                           <a:cs typeface="Calibri" pitchFamily="34" charset="-120"/>
                         </a:rPr>
-                        <a:t>US$ 1,3 mi</a:t>
+                        <a:t>US$ 1,1 mi</a:t>
                       </a:r>
                       <a:endParaRPr lang="en-US" sz="1150" dirty="0">
                         <a:latin typeface="Calibri" charset="0"/>
@@ -21858,7 +21858,7 @@
                           <a:ea typeface="Calibri" pitchFamily="34" charset="-122"/>
                           <a:cs typeface="Calibri" pitchFamily="34" charset="-120"/>
                         </a:rPr>
-                        <a:t>Campanha de Preservação de Costado - Pintura</a:t>
+                        <a:t>OSs CORRETIVAS - 307 Oss COM PEDIDO E VALOR</a:t>
                       </a:r>
                       <a:endParaRPr lang="en-US" sz="1150" dirty="0">
                         <a:latin typeface="Calibri" charset="0"/>
@@ -21926,7 +21926,7 @@
                           <a:ea typeface="Calibri" pitchFamily="34" charset="-122"/>
                           <a:cs typeface="Calibri" pitchFamily="34" charset="-120"/>
                         </a:rPr>
-                        <a:t>US$ 1,1 mi</a:t>
+                        <a:t>US$ 848,4 mil</a:t>
                       </a:r>
                       <a:endParaRPr lang="en-US" sz="1150" dirty="0">
                         <a:latin typeface="Calibri" charset="0"/>
@@ -22015,7 +22015,7 @@
                 <a:ea typeface="Calibri" pitchFamily="34" charset="-122"/>
                 <a:cs typeface="Calibri" pitchFamily="34" charset="-120"/>
               </a:rPr>
-              <a:t>Metodologia: Cost Allocation = OPEX, status 'Contar'/'TA', agrupado por escopo dentro de cada ativo.</a:t>
+              <a:t>Metodologia: Cost Allocation = OPEX, status 'Contar'/'TA', restrito às áreas priorizadas acima, agrupado por escopo dentro de cada ativo.</a:t>
             </a:r>
             <a:endParaRPr lang="en-US" sz="850" dirty="0"/>
           </a:p>
@@ -27078,7 +27078,7 @@
                 <a:ea typeface="Calibri" pitchFamily="34" charset="-122"/>
                 <a:cs typeface="Calibri" pitchFamily="34" charset="-120"/>
               </a:rPr>
-              <a:t>Ano 2027 · maiores escopos individuais de OPEX (status 'Contar' + 'TA'), dentro de cada ativo do grupo · OPEX total do grupo: US$ 32,3 mi</a:t>
+              <a:t>Ano 2027 · maiores escopos de OPEX nas áreas priorizadas (Manutenção, Suporte Técnico, Confiabilidade, Integridade, Naval, Construção, Projetos) · total nessas áreas: US$ 28,4 mi</a:t>
             </a:r>
             <a:endParaRPr lang="en-US" sz="1250" dirty="0"/>
           </a:p>
@@ -28635,7 +28635,7 @@
                 <a:ea typeface="Calibri" pitchFamily="34" charset="-122"/>
                 <a:cs typeface="Calibri" pitchFamily="34" charset="-120"/>
               </a:rPr>
-              <a:t>Metodologia: Cost Allocation = OPEX, status 'Contar'/'TA', agrupado por escopo dentro de cada ativo.</a:t>
+              <a:t>Metodologia: Cost Allocation = OPEX, status 'Contar'/'TA', restrito às áreas priorizadas acima, agrupado por escopo dentro de cada ativo.</a:t>
             </a:r>
             <a:endParaRPr lang="en-US" sz="850" dirty="0"/>
           </a:p>
@@ -33698,7 +33698,7 @@
                 <a:ea typeface="Calibri" pitchFamily="34" charset="-122"/>
                 <a:cs typeface="Calibri" pitchFamily="34" charset="-120"/>
               </a:rPr>
-              <a:t>Ano 2027 · maiores escopos individuais de OPEX (status 'Contar' + 'TA'), dentro de cada ativo do grupo · OPEX total do grupo: US$ 96,7 mi</a:t>
+              <a:t>Ano 2027 · maiores escopos de OPEX nas áreas priorizadas (Manutenção, Suporte Técnico, Confiabilidade, Integridade, Naval, Construção, Projetos) · total nessas áreas: US$ 40,3 mi</a:t>
             </a:r>
             <a:endParaRPr lang="en-US" sz="1250" dirty="0"/>
           </a:p>
@@ -33787,7 +33787,7 @@
                           <a:ea typeface="Calibri" pitchFamily="34" charset="-122"/>
                           <a:cs typeface="Calibri" pitchFamily="34" charset="-120"/>
                         </a:rPr>
-                        <a:t>Fixo - PRIO + OSM</a:t>
+                        <a:t>Time de Construção - Pintura</a:t>
                       </a:r>
                       <a:endParaRPr lang="en-US" sz="1000" dirty="0">
                         <a:latin typeface="Calibri" charset="0"/>
@@ -33855,7 +33855,7 @@
                           <a:ea typeface="Calibri" pitchFamily="34" charset="-122"/>
                           <a:cs typeface="Calibri" pitchFamily="34" charset="-120"/>
                         </a:rPr>
-                        <a:t>US$ 19,6 mi</a:t>
+                        <a:t>US$ 6,5 mi</a:t>
                       </a:r>
                       <a:endParaRPr lang="en-US" sz="1000" dirty="0">
                         <a:latin typeface="Calibri" charset="0"/>
@@ -33925,7 +33925,7 @@
                           <a:ea typeface="Calibri" pitchFamily="34" charset="-122"/>
                           <a:cs typeface="Calibri" pitchFamily="34" charset="-120"/>
                         </a:rPr>
-                        <a:t>Time de Construção - Pintura</a:t>
+                        <a:t>Time de Construção - Instalações (Fabric, Constr e Mont.)</a:t>
                       </a:r>
                       <a:endParaRPr lang="en-US" sz="1000" dirty="0">
                         <a:latin typeface="Calibri" charset="0"/>
@@ -33993,7 +33993,7 @@
                           <a:ea typeface="Calibri" pitchFamily="34" charset="-122"/>
                           <a:cs typeface="Calibri" pitchFamily="34" charset="-120"/>
                         </a:rPr>
-                        <a:t>US$ 6,5 mi</a:t>
+                        <a:t>US$ 2,0 mi</a:t>
                       </a:r>
                       <a:endParaRPr lang="en-US" sz="1000" dirty="0">
                         <a:latin typeface="Calibri" charset="0"/>
@@ -34063,7 +34063,7 @@
                           <a:ea typeface="Calibri" pitchFamily="34" charset="-122"/>
                           <a:cs typeface="Calibri" pitchFamily="34" charset="-120"/>
                         </a:rPr>
-                        <a:t>Time de Construção - Instalações (Fabric, Constr e Mont.)</a:t>
+                        <a:t>Inspeção Interna NR-13 FPSO</a:t>
                       </a:r>
                       <a:endParaRPr lang="en-US" sz="1000" dirty="0">
                         <a:latin typeface="Calibri" charset="0"/>
@@ -34131,7 +34131,7 @@
                           <a:ea typeface="Calibri" pitchFamily="34" charset="-122"/>
                           <a:cs typeface="Calibri" pitchFamily="34" charset="-120"/>
                         </a:rPr>
-                        <a:t>US$ 2,0 mi</a:t>
+                        <a:t>US$ 1,2 mi</a:t>
                       </a:r>
                       <a:endParaRPr lang="en-US" sz="1000" dirty="0">
                         <a:latin typeface="Calibri" charset="0"/>
@@ -34201,7 +34201,7 @@
                           <a:ea typeface="Calibri" pitchFamily="34" charset="-122"/>
                           <a:cs typeface="Calibri" pitchFamily="34" charset="-120"/>
                         </a:rPr>
-                        <a:t>Catering</a:t>
+                        <a:t>Campanha de Tanques</a:t>
                       </a:r>
                       <a:endParaRPr lang="en-US" sz="1000" dirty="0">
                         <a:latin typeface="Calibri" charset="0"/>
@@ -34269,7 +34269,7 @@
                           <a:ea typeface="Calibri" pitchFamily="34" charset="-122"/>
                           <a:cs typeface="Calibri" pitchFamily="34" charset="-120"/>
                         </a:rPr>
-                        <a:t>US$ 1,9 mi</a:t>
+                        <a:t>US$ 1,2 mi</a:t>
                       </a:r>
                       <a:endParaRPr lang="en-US" sz="1000" dirty="0">
                         <a:latin typeface="Calibri" charset="0"/>
@@ -34339,7 +34339,7 @@
                           <a:ea typeface="Calibri" pitchFamily="34" charset="-122"/>
                           <a:cs typeface="Calibri" pitchFamily="34" charset="-120"/>
                         </a:rPr>
-                        <a:t>Tratamento e Descarte de Água do Slop</a:t>
+                        <a:t>Campanha normatização de reparos</a:t>
                       </a:r>
                       <a:endParaRPr lang="en-US" sz="1000" dirty="0">
                         <a:latin typeface="Calibri" charset="0"/>
@@ -34407,7 +34407,7 @@
                           <a:ea typeface="Calibri" pitchFamily="34" charset="-122"/>
                           <a:cs typeface="Calibri" pitchFamily="34" charset="-120"/>
                         </a:rPr>
-                        <a:t>US$ 1,7 mi</a:t>
+                        <a:t>US$ 1,1 mi</a:t>
                       </a:r>
                       <a:endParaRPr lang="en-US" sz="1000" dirty="0">
                         <a:latin typeface="Calibri" charset="0"/>
@@ -34546,7 +34546,7 @@
                           <a:ea typeface="Calibri" pitchFamily="34" charset="-122"/>
                           <a:cs typeface="Calibri" pitchFamily="34" charset="-120"/>
                         </a:rPr>
-                        <a:t>Fixo - PRIO + OSM</a:t>
+                        <a:t>Time de Construção - Instalações (Fabric, Constr e Mont.)</a:t>
                       </a:r>
                       <a:endParaRPr lang="en-US" sz="1000" dirty="0">
                         <a:latin typeface="Calibri" charset="0"/>
@@ -34614,7 +34614,7 @@
                           <a:ea typeface="Calibri" pitchFamily="34" charset="-122"/>
                           <a:cs typeface="Calibri" pitchFamily="34" charset="-120"/>
                         </a:rPr>
-                        <a:t>US$ 6,7 mi</a:t>
+                        <a:t>US$ 1,5 mi</a:t>
                       </a:r>
                       <a:endParaRPr lang="en-US" sz="1000" dirty="0">
                         <a:latin typeface="Calibri" charset="0"/>
@@ -34684,7 +34684,7 @@
                           <a:ea typeface="Calibri" pitchFamily="34" charset="-122"/>
                           <a:cs typeface="Calibri" pitchFamily="34" charset="-120"/>
                         </a:rPr>
-                        <a:t>Catering</a:t>
+                        <a:t>Plano de Gerenciamento de Corrosão</a:t>
                       </a:r>
                       <a:endParaRPr lang="en-US" sz="1000" dirty="0">
                         <a:latin typeface="Calibri" charset="0"/>
@@ -34752,7 +34752,7 @@
                           <a:ea typeface="Calibri" pitchFamily="34" charset="-122"/>
                           <a:cs typeface="Calibri" pitchFamily="34" charset="-120"/>
                         </a:rPr>
-                        <a:t>US$ 1,6 mi</a:t>
+                        <a:t>US$ 976,2 mil</a:t>
                       </a:r>
                       <a:endParaRPr lang="en-US" sz="1000" dirty="0">
                         <a:latin typeface="Calibri" charset="0"/>
@@ -34822,7 +34822,7 @@
                           <a:ea typeface="Calibri" pitchFamily="34" charset="-122"/>
                           <a:cs typeface="Calibri" pitchFamily="34" charset="-120"/>
                         </a:rPr>
-                        <a:t>Time de Construção - Instalações (Fabric, Constr e Mont.)</a:t>
+                        <a:t>Inspeção Jackets</a:t>
                       </a:r>
                       <a:endParaRPr lang="en-US" sz="1000" dirty="0">
                         <a:latin typeface="Calibri" charset="0"/>
@@ -34890,7 +34890,7 @@
                           <a:ea typeface="Calibri" pitchFamily="34" charset="-122"/>
                           <a:cs typeface="Calibri" pitchFamily="34" charset="-120"/>
                         </a:rPr>
-                        <a:t>US$ 1,5 mi</a:t>
+                        <a:t>US$ 400,0 mil</a:t>
                       </a:r>
                       <a:endParaRPr lang="en-US" sz="1000" dirty="0">
                         <a:latin typeface="Calibri" charset="0"/>
@@ -34960,7 +34960,7 @@
                           <a:ea typeface="Calibri" pitchFamily="34" charset="-122"/>
                           <a:cs typeface="Calibri" pitchFamily="34" charset="-120"/>
                         </a:rPr>
-                        <a:t>Plano de Gerenciamento de Corrosão</a:t>
+                        <a:t>Time de Construção - Andaime</a:t>
                       </a:r>
                       <a:endParaRPr lang="en-US" sz="1000" dirty="0">
                         <a:latin typeface="Calibri" charset="0"/>
@@ -35028,7 +35028,7 @@
                           <a:ea typeface="Calibri" pitchFamily="34" charset="-122"/>
                           <a:cs typeface="Calibri" pitchFamily="34" charset="-120"/>
                         </a:rPr>
-                        <a:t>US$ 976,2 mil</a:t>
+                        <a:t>US$ 312,0 mil</a:t>
                       </a:r>
                       <a:endParaRPr lang="en-US" sz="1000" dirty="0">
                         <a:latin typeface="Calibri" charset="0"/>
@@ -35098,7 +35098,7 @@
                           <a:ea typeface="Calibri" pitchFamily="34" charset="-122"/>
                           <a:cs typeface="Calibri" pitchFamily="34" charset="-120"/>
                         </a:rPr>
-                        <a:t>Inspeção Jackets</a:t>
+                        <a:t>Campanha de normatização de reparos</a:t>
                       </a:r>
                       <a:endParaRPr lang="en-US" sz="1000" dirty="0">
                         <a:latin typeface="Calibri" charset="0"/>
@@ -35166,7 +35166,7 @@
                           <a:ea typeface="Calibri" pitchFamily="34" charset="-122"/>
                           <a:cs typeface="Calibri" pitchFamily="34" charset="-120"/>
                         </a:rPr>
-                        <a:t>US$ 400,0 mil</a:t>
+                        <a:t>US$ 273,0 mil</a:t>
                       </a:r>
                       <a:endParaRPr lang="en-US" sz="1000" dirty="0">
                         <a:latin typeface="Calibri" charset="0"/>
@@ -35305,7 +35305,7 @@
                           <a:ea typeface="Calibri" pitchFamily="34" charset="-122"/>
                           <a:cs typeface="Calibri" pitchFamily="34" charset="-120"/>
                         </a:rPr>
-                        <a:t>TIME FIXO PRIO</a:t>
+                        <a:t>Time de Construção - Instalações (Fabric, Constr, Mont e RTI.)</a:t>
                       </a:r>
                       <a:endParaRPr lang="en-US" sz="1000" dirty="0">
                         <a:latin typeface="Calibri" charset="0"/>
@@ -35373,7 +35373,7 @@
                           <a:ea typeface="Calibri" pitchFamily="34" charset="-122"/>
                           <a:cs typeface="Calibri" pitchFamily="34" charset="-120"/>
                         </a:rPr>
-                        <a:t>US$ 4,8 mi</a:t>
+                        <a:t>US$ 2,1 mi</a:t>
                       </a:r>
                       <a:endParaRPr lang="en-US" sz="1000" dirty="0">
                         <a:latin typeface="Calibri" charset="0"/>
@@ -35443,7 +35443,7 @@
                           <a:ea typeface="Calibri" pitchFamily="34" charset="-122"/>
                           <a:cs typeface="Calibri" pitchFamily="34" charset="-120"/>
                         </a:rPr>
-                        <a:t>Time de Construção - Instalações (Fabric, Constr, Mont e RTI.)</a:t>
+                        <a:t>Plano de Gerenciamento de Corrosão</a:t>
                       </a:r>
                       <a:endParaRPr lang="en-US" sz="1000" dirty="0">
                         <a:latin typeface="Calibri" charset="0"/>
@@ -35511,7 +35511,7 @@
                           <a:ea typeface="Calibri" pitchFamily="34" charset="-122"/>
                           <a:cs typeface="Calibri" pitchFamily="34" charset="-120"/>
                         </a:rPr>
-                        <a:t>US$ 2,1 mi</a:t>
+                        <a:t>US$ 1,3 mi</a:t>
                       </a:r>
                       <a:endParaRPr lang="en-US" sz="1000" dirty="0">
                         <a:latin typeface="Calibri" charset="0"/>
@@ -35581,7 +35581,7 @@
                           <a:ea typeface="Calibri" pitchFamily="34" charset="-122"/>
                           <a:cs typeface="Calibri" pitchFamily="34" charset="-120"/>
                         </a:rPr>
-                        <a:t>TIME FIXO OSM</a:t>
+                        <a:t>Substituição/ Reparo dos Caissons - Abrangência</a:t>
                       </a:r>
                       <a:endParaRPr lang="en-US" sz="1000" dirty="0">
                         <a:latin typeface="Calibri" charset="0"/>
@@ -35649,7 +35649,7 @@
                           <a:ea typeface="Calibri" pitchFamily="34" charset="-122"/>
                           <a:cs typeface="Calibri" pitchFamily="34" charset="-120"/>
                         </a:rPr>
-                        <a:t>US$ 1,9 mi</a:t>
+                        <a:t>US$ 1,2 mi</a:t>
                       </a:r>
                       <a:endParaRPr lang="en-US" sz="1000" dirty="0">
                         <a:latin typeface="Calibri" charset="0"/>
@@ -35719,7 +35719,7 @@
                           <a:ea typeface="Calibri" pitchFamily="34" charset="-122"/>
                           <a:cs typeface="Calibri" pitchFamily="34" charset="-120"/>
                         </a:rPr>
-                        <a:t>TIME FIXO SODEXO</a:t>
+                        <a:t>Plano de Inspeção de sistemas de tubulação</a:t>
                       </a:r>
                       <a:endParaRPr lang="en-US" sz="1000" dirty="0">
                         <a:latin typeface="Calibri" charset="0"/>
@@ -35787,7 +35787,7 @@
                           <a:ea typeface="Calibri" pitchFamily="34" charset="-122"/>
                           <a:cs typeface="Calibri" pitchFamily="34" charset="-120"/>
                         </a:rPr>
-                        <a:t>US$ 1,6 mi</a:t>
+                        <a:t>US$ 567,0 mil</a:t>
                       </a:r>
                       <a:endParaRPr lang="en-US" sz="1000" dirty="0">
                         <a:latin typeface="Calibri" charset="0"/>
@@ -35857,7 +35857,7 @@
                           <a:ea typeface="Calibri" pitchFamily="34" charset="-122"/>
                           <a:cs typeface="Calibri" pitchFamily="34" charset="-120"/>
                         </a:rPr>
-                        <a:t>Plano de Gerenciamento de Corrosão</a:t>
+                        <a:t>Inspeção de Jackets</a:t>
                       </a:r>
                       <a:endParaRPr lang="en-US" sz="1000" dirty="0">
                         <a:latin typeface="Calibri" charset="0"/>
@@ -35925,7 +35925,7 @@
                           <a:ea typeface="Calibri" pitchFamily="34" charset="-122"/>
                           <a:cs typeface="Calibri" pitchFamily="34" charset="-120"/>
                         </a:rPr>
-                        <a:t>US$ 1,3 mi</a:t>
+                        <a:t>US$ 400,0 mil</a:t>
                       </a:r>
                       <a:endParaRPr lang="en-US" sz="1000" dirty="0">
                         <a:latin typeface="Calibri" charset="0"/>
@@ -36064,7 +36064,7 @@
                           <a:ea typeface="Calibri" pitchFamily="34" charset="-122"/>
                           <a:cs typeface="Calibri" pitchFamily="34" charset="-120"/>
                         </a:rPr>
-                        <a:t>TIME FIXO PRIO</a:t>
+                        <a:t>Time de Construção - Instalações (Fabric, Constr e Mont.)</a:t>
                       </a:r>
                       <a:endParaRPr lang="en-US" sz="1000" dirty="0">
                         <a:latin typeface="Calibri" charset="0"/>
@@ -36132,7 +36132,7 @@
                           <a:ea typeface="Calibri" pitchFamily="34" charset="-122"/>
                           <a:cs typeface="Calibri" pitchFamily="34" charset="-120"/>
                         </a:rPr>
-                        <a:t>US$ 5,6 mi</a:t>
+                        <a:t>US$ 3,3 mi</a:t>
                       </a:r>
                       <a:endParaRPr lang="en-US" sz="1000" dirty="0">
                         <a:latin typeface="Calibri" charset="0"/>
@@ -36202,7 +36202,7 @@
                           <a:ea typeface="Calibri" pitchFamily="34" charset="-122"/>
                           <a:cs typeface="Calibri" pitchFamily="34" charset="-120"/>
                         </a:rPr>
-                        <a:t>Time de Construção - Instalações (Fabric, Constr e Mont.)</a:t>
+                        <a:t>Manutenção Preventiva (L1) da GTG-A</a:t>
                       </a:r>
                       <a:endParaRPr lang="en-US" sz="1000" dirty="0">
                         <a:latin typeface="Calibri" charset="0"/>
@@ -36270,7 +36270,7 @@
                           <a:ea typeface="Calibri" pitchFamily="34" charset="-122"/>
                           <a:cs typeface="Calibri" pitchFamily="34" charset="-120"/>
                         </a:rPr>
-                        <a:t>US$ 3,3 mi</a:t>
+                        <a:t>US$ 708,5 mil</a:t>
                       </a:r>
                       <a:endParaRPr lang="en-US" sz="1000" dirty="0">
                         <a:latin typeface="Calibri" charset="0"/>
@@ -36340,7 +36340,7 @@
                           <a:ea typeface="Calibri" pitchFamily="34" charset="-122"/>
                           <a:cs typeface="Calibri" pitchFamily="34" charset="-120"/>
                         </a:rPr>
-                        <a:t>TIME FIXO OSM</a:t>
+                        <a:t>Manutenção Preventiva (L1) da GTG-B</a:t>
                       </a:r>
                       <a:endParaRPr lang="en-US" sz="1000" dirty="0">
                         <a:latin typeface="Calibri" charset="0"/>
@@ -36408,7 +36408,7 @@
                           <a:ea typeface="Calibri" pitchFamily="34" charset="-122"/>
                           <a:cs typeface="Calibri" pitchFamily="34" charset="-120"/>
                         </a:rPr>
-                        <a:t>US$ 2,2 mi</a:t>
+                        <a:t>US$ 708,5 mil</a:t>
                       </a:r>
                       <a:endParaRPr lang="en-US" sz="1000" dirty="0">
                         <a:latin typeface="Calibri" charset="0"/>
@@ -36478,7 +36478,7 @@
                           <a:ea typeface="Calibri" pitchFamily="34" charset="-122"/>
                           <a:cs typeface="Calibri" pitchFamily="34" charset="-120"/>
                         </a:rPr>
-                        <a:t>TIME FIXO SODEXO</a:t>
+                        <a:t>Plano de Inspeção de sistemas de tubulação</a:t>
                       </a:r>
                       <a:endParaRPr lang="en-US" sz="1000" dirty="0">
                         <a:latin typeface="Calibri" charset="0"/>
@@ -36546,7 +36546,7 @@
                           <a:ea typeface="Calibri" pitchFamily="34" charset="-122"/>
                           <a:cs typeface="Calibri" pitchFamily="34" charset="-120"/>
                         </a:rPr>
-                        <a:t>US$ 2,1 mi</a:t>
+                        <a:t>US$ 567,0 mil</a:t>
                       </a:r>
                       <a:endParaRPr lang="en-US" sz="1000" dirty="0">
                         <a:latin typeface="Calibri" charset="0"/>
@@ -36616,7 +36616,7 @@
                           <a:ea typeface="Calibri" pitchFamily="34" charset="-122"/>
                           <a:cs typeface="Calibri" pitchFamily="34" charset="-120"/>
                         </a:rPr>
-                        <a:t>Manutenção Preventiva (L1) da GTG-A</a:t>
+                        <a:t>Time de Construção - Pintura</a:t>
                       </a:r>
                       <a:endParaRPr lang="en-US" sz="1000" dirty="0">
                         <a:latin typeface="Calibri" charset="0"/>
@@ -36684,7 +36684,7 @@
                           <a:ea typeface="Calibri" pitchFamily="34" charset="-122"/>
                           <a:cs typeface="Calibri" pitchFamily="34" charset="-120"/>
                         </a:rPr>
-                        <a:t>US$ 708,5 mil</a:t>
+                        <a:t>US$ 564,0 mil</a:t>
                       </a:r>
                       <a:endParaRPr lang="en-US" sz="1000" dirty="0">
                         <a:latin typeface="Calibri" charset="0"/>
@@ -36773,7 +36773,7 @@
                 <a:ea typeface="Calibri" pitchFamily="34" charset="-122"/>
                 <a:cs typeface="Calibri" pitchFamily="34" charset="-120"/>
               </a:rPr>
-              <a:t>Metodologia: Cost Allocation = OPEX, status 'Contar'/'TA', agrupado por escopo dentro de cada ativo.</a:t>
+              <a:t>Metodologia: Cost Allocation = OPEX, status 'Contar'/'TA', restrito às áreas priorizadas acima, agrupado por escopo dentro de cada ativo.</a:t>
             </a:r>
             <a:endParaRPr lang="en-US" sz="850" dirty="0"/>
           </a:p>

</xml_diff>

<commit_message>
Apply requesting-area priority filter to per-group Top 10 CAPEX too
The Top 10 CAPEX slides were still unrestricted, surfacing scopes from
departments outside the requested priority areas (e.g. "Reforma do
Casario - Acomodação" under ADM - Administrativo for FPSO Frade). Now
restricted to the same priority areas already applied to the Top 5
OPEX panels: Manutenção, Suporte Técnico, Confiabilidade, Integridade,
Naval, Construção, Projetos.
</commit_message>
<xml_diff>
--- a/PRIO_Top_CAPEX_OPEX_Despriorizados_2027.pptx
+++ b/PRIO_Top_CAPEX_OPEX_Despriorizados_2027.pptx
@@ -16394,7 +16394,7 @@
                 <a:ea typeface="Calibri" pitchFamily="34" charset="-122"/>
                 <a:cs typeface="Calibri" pitchFamily="34" charset="-120"/>
               </a:rPr>
-              <a:t>Ano 2027 · maiores escopos individuais de CAPEX (status 'Contar' + 'TA') · CAPEX total do grupo: US$ 58,7 mi</a:t>
+              <a:t>Ano 2027 · maiores escopos de CAPEX nas áreas priorizadas (Manutenção, Suporte Técnico, Confiabilidade, Integridade, Naval, Construção, Projetos) · total nessas áreas: US$ 50,8 mi</a:t>
             </a:r>
             <a:endParaRPr lang="en-US" sz="1250" dirty="0"/>
           </a:p>
@@ -18976,7 +18976,7 @@
                           <a:ea typeface="Calibri" pitchFamily="34" charset="-122"/>
                           <a:cs typeface="Calibri" pitchFamily="34" charset="-120"/>
                         </a:rPr>
-                        <a:t>Reforma do Casario - Acomodação</a:t>
+                        <a:t>REVAMP IGG</a:t>
                       </a:r>
                       <a:endParaRPr lang="en-US" sz="1000" dirty="0">
                         <a:latin typeface="Calibri" charset="0"/>
@@ -19112,7 +19112,7 @@
                           <a:ea typeface="Calibri" pitchFamily="34" charset="-122"/>
                           <a:cs typeface="Calibri" pitchFamily="34" charset="-120"/>
                         </a:rPr>
-                        <a:t>ADM - Administrativo</a:t>
+                        <a:t>MNT – Manutenção</a:t>
                       </a:r>
                       <a:endParaRPr lang="en-US" sz="900" dirty="0">
                         <a:latin typeface="Calibri" charset="0"/>
@@ -19180,7 +19180,7 @@
                           <a:ea typeface="Calibri" pitchFamily="34" charset="-122"/>
                           <a:cs typeface="Calibri" pitchFamily="34" charset="-120"/>
                         </a:rPr>
-                        <a:t>Bem Estar/Segurança</a:t>
+                        <a:t>Rotina Operacional</a:t>
                       </a:r>
                       <a:endParaRPr lang="en-US" sz="900" dirty="0">
                         <a:latin typeface="Calibri" charset="0"/>
@@ -19248,7 +19248,7 @@
                           <a:ea typeface="Calibri" pitchFamily="34" charset="-122"/>
                           <a:cs typeface="Calibri" pitchFamily="34" charset="-120"/>
                         </a:rPr>
-                        <a:t>US$ 2,1 mi</a:t>
+                        <a:t>US$ 1,6 mi</a:t>
                       </a:r>
                       <a:endParaRPr lang="en-US" sz="1000" dirty="0">
                         <a:latin typeface="Calibri" charset="0"/>
@@ -19386,7 +19386,7 @@
                           <a:ea typeface="Calibri" pitchFamily="34" charset="-122"/>
                           <a:cs typeface="Calibri" pitchFamily="34" charset="-120"/>
                         </a:rPr>
-                        <a:t>REVAMP IGG</a:t>
+                        <a:t>Substituição Gerador de Nitrogênio</a:t>
                       </a:r>
                       <a:endParaRPr lang="en-US" sz="1000" dirty="0">
                         <a:latin typeface="Calibri" charset="0"/>
@@ -19522,7 +19522,7 @@
                           <a:ea typeface="Calibri" pitchFamily="34" charset="-122"/>
                           <a:cs typeface="Calibri" pitchFamily="34" charset="-120"/>
                         </a:rPr>
-                        <a:t>MNT – Manutenção</a:t>
+                        <a:t>Projetos</a:t>
                       </a:r>
                       <a:endParaRPr lang="en-US" sz="900" dirty="0">
                         <a:latin typeface="Calibri" charset="0"/>
@@ -19590,7 +19590,7 @@
                           <a:ea typeface="Calibri" pitchFamily="34" charset="-122"/>
                           <a:cs typeface="Calibri" pitchFamily="34" charset="-120"/>
                         </a:rPr>
-                        <a:t>Rotina Operacional</a:t>
+                        <a:t>Eficiência de Produção</a:t>
                       </a:r>
                       <a:endParaRPr lang="en-US" sz="900" dirty="0">
                         <a:latin typeface="Calibri" charset="0"/>
@@ -19658,7 +19658,7 @@
                           <a:ea typeface="Calibri" pitchFamily="34" charset="-122"/>
                           <a:cs typeface="Calibri" pitchFamily="34" charset="-120"/>
                         </a:rPr>
-                        <a:t>US$ 1,6 mi</a:t>
+                        <a:t>US$ 1,4 mi</a:t>
                       </a:r>
                       <a:endParaRPr lang="en-US" sz="1000" dirty="0">
                         <a:latin typeface="Calibri" charset="0"/>
@@ -19796,7 +19796,7 @@
                           <a:ea typeface="Calibri" pitchFamily="34" charset="-122"/>
                           <a:cs typeface="Calibri" pitchFamily="34" charset="-120"/>
                         </a:rPr>
-                        <a:t>Substituição Gerador de Nitrogênio</a:t>
+                        <a:t>Skids de Dilúvio</a:t>
                       </a:r>
                       <a:endParaRPr lang="en-US" sz="1000" dirty="0">
                         <a:latin typeface="Calibri" charset="0"/>
@@ -20000,7 +20000,7 @@
                           <a:ea typeface="Calibri" pitchFamily="34" charset="-122"/>
                           <a:cs typeface="Calibri" pitchFamily="34" charset="-120"/>
                         </a:rPr>
-                        <a:t>Eficiência de Produção</a:t>
+                        <a:t>Bem Estar/Segurança</a:t>
                       </a:r>
                       <a:endParaRPr lang="en-US" sz="900" dirty="0">
                         <a:latin typeface="Calibri" charset="0"/>
@@ -20068,7 +20068,7 @@
                           <a:ea typeface="Calibri" pitchFamily="34" charset="-122"/>
                           <a:cs typeface="Calibri" pitchFamily="34" charset="-120"/>
                         </a:rPr>
-                        <a:t>US$ 1,4 mi</a:t>
+                        <a:t>US$ 1,3 mi</a:t>
                       </a:r>
                       <a:endParaRPr lang="en-US" sz="1000" dirty="0">
                         <a:latin typeface="Calibri" charset="0"/>
@@ -20206,7 +20206,7 @@
                           <a:ea typeface="Calibri" pitchFamily="34" charset="-122"/>
                           <a:cs typeface="Calibri" pitchFamily="34" charset="-120"/>
                         </a:rPr>
-                        <a:t>Skids de Dilúvio</a:t>
+                        <a:t>Sensores de H2S</a:t>
                       </a:r>
                       <a:endParaRPr lang="en-US" sz="1000" dirty="0">
                         <a:latin typeface="Calibri" charset="0"/>
@@ -20478,7 +20478,7 @@
                           <a:ea typeface="Calibri" pitchFamily="34" charset="-122"/>
                           <a:cs typeface="Calibri" pitchFamily="34" charset="-120"/>
                         </a:rPr>
-                        <a:t>US$ 1,3 mi</a:t>
+                        <a:t>US$ 1,2 mi</a:t>
                       </a:r>
                       <a:endParaRPr lang="en-US" sz="1000" dirty="0">
                         <a:latin typeface="Calibri" charset="0"/>
@@ -20616,7 +20616,7 @@
                           <a:ea typeface="Calibri" pitchFamily="34" charset="-122"/>
                           <a:cs typeface="Calibri" pitchFamily="34" charset="-120"/>
                         </a:rPr>
-                        <a:t>Sensores de H2S</a:t>
+                        <a:t>TROCADOR DE CALOR DO GERADOR - GT4</a:t>
                       </a:r>
                       <a:endParaRPr lang="en-US" sz="1000" dirty="0">
                         <a:latin typeface="Calibri" charset="0"/>
@@ -20752,7 +20752,7 @@
                           <a:ea typeface="Calibri" pitchFamily="34" charset="-122"/>
                           <a:cs typeface="Calibri" pitchFamily="34" charset="-120"/>
                         </a:rPr>
-                        <a:t>Projetos</a:t>
+                        <a:t>MNT – Manutenção</a:t>
                       </a:r>
                       <a:endParaRPr lang="en-US" sz="900" dirty="0">
                         <a:latin typeface="Calibri" charset="0"/>
@@ -20820,7 +20820,7 @@
                           <a:ea typeface="Calibri" pitchFamily="34" charset="-122"/>
                           <a:cs typeface="Calibri" pitchFamily="34" charset="-120"/>
                         </a:rPr>
-                        <a:t>Bem Estar/Segurança</a:t>
+                        <a:t>Rotina Operacional</a:t>
                       </a:r>
                       <a:endParaRPr lang="en-US" sz="900" dirty="0">
                         <a:latin typeface="Calibri" charset="0"/>
@@ -20888,7 +20888,7 @@
                           <a:ea typeface="Calibri" pitchFamily="34" charset="-122"/>
                           <a:cs typeface="Calibri" pitchFamily="34" charset="-120"/>
                         </a:rPr>
-                        <a:t>US$ 1,2 mi</a:t>
+                        <a:t>US$ 1,1 mi</a:t>
                       </a:r>
                       <a:endParaRPr lang="en-US" sz="1000" dirty="0">
                         <a:latin typeface="Calibri" charset="0"/>
@@ -20977,7 +20977,7 @@
                 <a:ea typeface="Calibri" pitchFamily="34" charset="-122"/>
                 <a:cs typeface="Calibri" pitchFamily="34" charset="-120"/>
               </a:rPr>
-              <a:t>Metodologia: Cost Allocation = CAPEX, status 'Contar'/'TA', excl. Desenvolvimento de Produção. Soma do top 10: US$ 42,3 mi (72,0% do CAPEX do grupo).</a:t>
+              <a:t>Metodologia: Cost Allocation = CAPEX, status 'Contar'/'TA', restrito às áreas priorizadas acima, excl. Desenvolvimento de Produção. Soma do top 10: US$ 41,4 mi (81,4% do CAPEX nessas áreas).</a:t>
             </a:r>
             <a:endParaRPr lang="en-US" sz="850" dirty="0"/>
           </a:p>
@@ -22255,7 +22255,7 @@
                 <a:ea typeface="Calibri" pitchFamily="34" charset="-122"/>
                 <a:cs typeface="Calibri" pitchFamily="34" charset="-120"/>
               </a:rPr>
-              <a:t>Ano 2027 · maiores escopos individuais de CAPEX (status 'Contar' + 'TA') · CAPEX total do grupo: US$ 21,9 mi</a:t>
+              <a:t>Ano 2027 · maiores escopos de CAPEX nas áreas priorizadas (Manutenção, Suporte Técnico, Confiabilidade, Integridade, Naval, Construção, Projetos) · total nessas áreas: US$ 10,9 mi</a:t>
             </a:r>
             <a:endParaRPr lang="en-US" sz="1250" dirty="0"/>
           </a:p>
@@ -23197,7 +23197,7 @@
                           <a:ea typeface="Calibri" pitchFamily="34" charset="-122"/>
                           <a:cs typeface="Calibri" pitchFamily="34" charset="-120"/>
                         </a:rPr>
-                        <a:t>TA - Mecânica</a:t>
+                        <a:t>Retrofit do Motor - Bomba de Incêndio</a:t>
                       </a:r>
                       <a:endParaRPr lang="en-US" sz="1000" dirty="0">
                         <a:latin typeface="Calibri" charset="0"/>
@@ -23265,7 +23265,7 @@
                           <a:ea typeface="Calibri" pitchFamily="34" charset="-122"/>
                           <a:cs typeface="Calibri" pitchFamily="34" charset="-120"/>
                         </a:rPr>
-                        <a:t>FPSO Bravo</a:t>
+                        <a:t>Polvo A</a:t>
                       </a:r>
                       <a:endParaRPr lang="en-US" sz="950" dirty="0">
                         <a:latin typeface="Calibri" charset="0"/>
@@ -23333,7 +23333,7 @@
                           <a:ea typeface="Calibri" pitchFamily="34" charset="-122"/>
                           <a:cs typeface="Calibri" pitchFamily="34" charset="-120"/>
                         </a:rPr>
-                        <a:t>TA - Parada Programada</a:t>
+                        <a:t>Projetos</a:t>
                       </a:r>
                       <a:endParaRPr lang="en-US" sz="900" dirty="0">
                         <a:latin typeface="Calibri" charset="0"/>
@@ -23401,7 +23401,7 @@
                           <a:ea typeface="Calibri" pitchFamily="34" charset="-122"/>
                           <a:cs typeface="Calibri" pitchFamily="34" charset="-120"/>
                         </a:rPr>
-                        <a:t>Eficiência de Produção</a:t>
+                        <a:t>Integridade e Regulatório</a:t>
                       </a:r>
                       <a:endParaRPr lang="en-US" sz="900" dirty="0">
                         <a:latin typeface="Calibri" charset="0"/>
@@ -23469,7 +23469,7 @@
                           <a:ea typeface="Calibri" pitchFamily="34" charset="-122"/>
                           <a:cs typeface="Calibri" pitchFamily="34" charset="-120"/>
                         </a:rPr>
-                        <a:t>US$ 1,5 mi</a:t>
+                        <a:t>US$ 863,1 mil</a:t>
                       </a:r>
                       <a:endParaRPr lang="en-US" sz="1000" dirty="0">
                         <a:latin typeface="Calibri" charset="0"/>
@@ -23607,7 +23607,7 @@
                           <a:ea typeface="Calibri" pitchFamily="34" charset="-122"/>
                           <a:cs typeface="Calibri" pitchFamily="34" charset="-120"/>
                         </a:rPr>
-                        <a:t>TA - Swivel - Pacote Hidráulico (OneSubsea)</a:t>
+                        <a:t>REVAMP CARGO PUMP - Nº 2</a:t>
                       </a:r>
                       <a:endParaRPr lang="en-US" sz="1000" dirty="0">
                         <a:latin typeface="Calibri" charset="0"/>
@@ -23743,7 +23743,7 @@
                           <a:ea typeface="Calibri" pitchFamily="34" charset="-122"/>
                           <a:cs typeface="Calibri" pitchFamily="34" charset="-120"/>
                         </a:rPr>
-                        <a:t>P&amp;Q - Processos</a:t>
+                        <a:t>EIM - Manutenção &amp; Integridade</a:t>
                       </a:r>
                       <a:endParaRPr lang="en-US" sz="900" dirty="0">
                         <a:latin typeface="Calibri" charset="0"/>
@@ -23811,7 +23811,7 @@
                           <a:ea typeface="Calibri" pitchFamily="34" charset="-122"/>
                           <a:cs typeface="Calibri" pitchFamily="34" charset="-120"/>
                         </a:rPr>
-                        <a:t>Integridade e Regulatório</a:t>
+                        <a:t>Rotina Operacional</a:t>
                       </a:r>
                       <a:endParaRPr lang="en-US" sz="900" dirty="0">
                         <a:latin typeface="Calibri" charset="0"/>
@@ -23879,7 +23879,7 @@
                           <a:ea typeface="Calibri" pitchFamily="34" charset="-122"/>
                           <a:cs typeface="Calibri" pitchFamily="34" charset="-120"/>
                         </a:rPr>
-                        <a:t>US$ 1,4 mi</a:t>
+                        <a:t>US$ 687,0 mil</a:t>
                       </a:r>
                       <a:endParaRPr lang="en-US" sz="1000" dirty="0">
                         <a:latin typeface="Calibri" charset="0"/>
@@ -24017,7 +24017,7 @@
                           <a:ea typeface="Calibri" pitchFamily="34" charset="-122"/>
                           <a:cs typeface="Calibri" pitchFamily="34" charset="-120"/>
                         </a:rPr>
-                        <a:t>TA - Elétrica</a:t>
+                        <a:t>Revitalização do compressor de Ar de Instrumento</a:t>
                       </a:r>
                       <a:endParaRPr lang="en-US" sz="1000" dirty="0">
                         <a:latin typeface="Calibri" charset="0"/>
@@ -24085,7 +24085,7 @@
                           <a:ea typeface="Calibri" pitchFamily="34" charset="-122"/>
                           <a:cs typeface="Calibri" pitchFamily="34" charset="-120"/>
                         </a:rPr>
-                        <a:t>FPSO Bravo</a:t>
+                        <a:t>Polvo A</a:t>
                       </a:r>
                       <a:endParaRPr lang="en-US" sz="950" dirty="0">
                         <a:latin typeface="Calibri" charset="0"/>
@@ -24153,7 +24153,7 @@
                           <a:ea typeface="Calibri" pitchFamily="34" charset="-122"/>
                           <a:cs typeface="Calibri" pitchFamily="34" charset="-120"/>
                         </a:rPr>
-                        <a:t>TA - Parada Programada</a:t>
+                        <a:t>Projetos</a:t>
                       </a:r>
                       <a:endParaRPr lang="en-US" sz="900" dirty="0">
                         <a:latin typeface="Calibri" charset="0"/>
@@ -24289,7 +24289,7 @@
                           <a:ea typeface="Calibri" pitchFamily="34" charset="-122"/>
                           <a:cs typeface="Calibri" pitchFamily="34" charset="-120"/>
                         </a:rPr>
-                        <a:t>US$ 982,4 mil</a:t>
+                        <a:t>US$ 544,8 mil</a:t>
                       </a:r>
                       <a:endParaRPr lang="en-US" sz="1000" dirty="0">
                         <a:latin typeface="Calibri" charset="0"/>
@@ -24427,7 +24427,7 @@
                           <a:ea typeface="Calibri" pitchFamily="34" charset="-122"/>
                           <a:cs typeface="Calibri" pitchFamily="34" charset="-120"/>
                         </a:rPr>
-                        <a:t>Retrofit do Motor - Bomba de Incêndio</a:t>
+                        <a:t>TA - Compra de Placas de controle dos VFDs Rockwell</a:t>
                       </a:r>
                       <a:endParaRPr lang="en-US" sz="1000" dirty="0">
                         <a:latin typeface="Calibri" charset="0"/>
@@ -24563,7 +24563,7 @@
                           <a:ea typeface="Calibri" pitchFamily="34" charset="-122"/>
                           <a:cs typeface="Calibri" pitchFamily="34" charset="-120"/>
                         </a:rPr>
-                        <a:t>Projetos</a:t>
+                        <a:t>EIM - Manutenção &amp; Integridade</a:t>
                       </a:r>
                       <a:endParaRPr lang="en-US" sz="900" dirty="0">
                         <a:latin typeface="Calibri" charset="0"/>
@@ -24631,7 +24631,7 @@
                           <a:ea typeface="Calibri" pitchFamily="34" charset="-122"/>
                           <a:cs typeface="Calibri" pitchFamily="34" charset="-120"/>
                         </a:rPr>
-                        <a:t>Integridade e Regulatório</a:t>
+                        <a:t>Rotina Operacional</a:t>
                       </a:r>
                       <a:endParaRPr lang="en-US" sz="900" dirty="0">
                         <a:latin typeface="Calibri" charset="0"/>
@@ -24699,7 +24699,7 @@
                           <a:ea typeface="Calibri" pitchFamily="34" charset="-122"/>
                           <a:cs typeface="Calibri" pitchFamily="34" charset="-120"/>
                         </a:rPr>
-                        <a:t>US$ 863,1 mil</a:t>
+                        <a:t>US$ 526,1 mil</a:t>
                       </a:r>
                       <a:endParaRPr lang="en-US" sz="1000" dirty="0">
                         <a:latin typeface="Calibri" charset="0"/>
@@ -24837,7 +24837,7 @@
                           <a:ea typeface="Calibri" pitchFamily="34" charset="-122"/>
                           <a:cs typeface="Calibri" pitchFamily="34" charset="-120"/>
                         </a:rPr>
-                        <a:t>TA - Caldeiraria</a:t>
+                        <a:t>MPP - Adequação do sistema de Selagem Multifásica</a:t>
                       </a:r>
                       <a:endParaRPr lang="en-US" sz="1000" dirty="0">
                         <a:latin typeface="Calibri" charset="0"/>
@@ -24905,7 +24905,7 @@
                           <a:ea typeface="Calibri" pitchFamily="34" charset="-122"/>
                           <a:cs typeface="Calibri" pitchFamily="34" charset="-120"/>
                         </a:rPr>
-                        <a:t>FPSO Bravo</a:t>
+                        <a:t>Polvo A</a:t>
                       </a:r>
                       <a:endParaRPr lang="en-US" sz="950" dirty="0">
                         <a:latin typeface="Calibri" charset="0"/>
@@ -24973,7 +24973,7 @@
                           <a:ea typeface="Calibri" pitchFamily="34" charset="-122"/>
                           <a:cs typeface="Calibri" pitchFamily="34" charset="-120"/>
                         </a:rPr>
-                        <a:t>TA - Parada Programada</a:t>
+                        <a:t>EIM - Manutenção &amp; Integridade</a:t>
                       </a:r>
                       <a:endParaRPr lang="en-US" sz="900" dirty="0">
                         <a:latin typeface="Calibri" charset="0"/>
@@ -25041,7 +25041,7 @@
                           <a:ea typeface="Calibri" pitchFamily="34" charset="-122"/>
                           <a:cs typeface="Calibri" pitchFamily="34" charset="-120"/>
                         </a:rPr>
-                        <a:t>Eficiência de Produção</a:t>
+                        <a:t>Rotina Operacional</a:t>
                       </a:r>
                       <a:endParaRPr lang="en-US" sz="900" dirty="0">
                         <a:latin typeface="Calibri" charset="0"/>
@@ -25109,7 +25109,7 @@
                           <a:ea typeface="Calibri" pitchFamily="34" charset="-122"/>
                           <a:cs typeface="Calibri" pitchFamily="34" charset="-120"/>
                         </a:rPr>
-                        <a:t>US$ 816,1 mil</a:t>
+                        <a:t>US$ 519,2 mil</a:t>
                       </a:r>
                       <a:endParaRPr lang="en-US" sz="1000" dirty="0">
                         <a:latin typeface="Calibri" charset="0"/>
@@ -25247,7 +25247,7 @@
                           <a:ea typeface="Calibri" pitchFamily="34" charset="-122"/>
                           <a:cs typeface="Calibri" pitchFamily="34" charset="-120"/>
                         </a:rPr>
-                        <a:t>REVAMP CARGO PUMP - Nº 2</a:t>
+                        <a:t>Instalação de novos Detectores de Gás</a:t>
                       </a:r>
                       <a:endParaRPr lang="en-US" sz="1000" dirty="0">
                         <a:latin typeface="Calibri" charset="0"/>
@@ -25315,7 +25315,7 @@
                           <a:ea typeface="Calibri" pitchFamily="34" charset="-122"/>
                           <a:cs typeface="Calibri" pitchFamily="34" charset="-120"/>
                         </a:rPr>
-                        <a:t>FPSO Bravo</a:t>
+                        <a:t>Polvo A</a:t>
                       </a:r>
                       <a:endParaRPr lang="en-US" sz="950" dirty="0">
                         <a:latin typeface="Calibri" charset="0"/>
@@ -25383,7 +25383,7 @@
                           <a:ea typeface="Calibri" pitchFamily="34" charset="-122"/>
                           <a:cs typeface="Calibri" pitchFamily="34" charset="-120"/>
                         </a:rPr>
-                        <a:t>EIM - Manutenção &amp; Integridade</a:t>
+                        <a:t>Projetos</a:t>
                       </a:r>
                       <a:endParaRPr lang="en-US" sz="900" dirty="0">
                         <a:latin typeface="Calibri" charset="0"/>
@@ -25451,7 +25451,7 @@
                           <a:ea typeface="Calibri" pitchFamily="34" charset="-122"/>
                           <a:cs typeface="Calibri" pitchFamily="34" charset="-120"/>
                         </a:rPr>
-                        <a:t>Rotina Operacional</a:t>
+                        <a:t>Integridade e Regulatório</a:t>
                       </a:r>
                       <a:endParaRPr lang="en-US" sz="900" dirty="0">
                         <a:latin typeface="Calibri" charset="0"/>
@@ -25519,7 +25519,7 @@
                           <a:ea typeface="Calibri" pitchFamily="34" charset="-122"/>
                           <a:cs typeface="Calibri" pitchFamily="34" charset="-120"/>
                         </a:rPr>
-                        <a:t>US$ 687,0 mil</a:t>
+                        <a:t>US$ 447,3 mil</a:t>
                       </a:r>
                       <a:endParaRPr lang="en-US" sz="1000" dirty="0">
                         <a:latin typeface="Calibri" charset="0"/>
@@ -25657,7 +25657,7 @@
                           <a:ea typeface="Calibri" pitchFamily="34" charset="-122"/>
                           <a:cs typeface="Calibri" pitchFamily="34" charset="-120"/>
                         </a:rPr>
-                        <a:t>TA - NR13</a:t>
+                        <a:t>TA - Manutenção no Swivel elétrico</a:t>
                       </a:r>
                       <a:endParaRPr lang="en-US" sz="1000" dirty="0">
                         <a:latin typeface="Calibri" charset="0"/>
@@ -25793,7 +25793,7 @@
                           <a:ea typeface="Calibri" pitchFamily="34" charset="-122"/>
                           <a:cs typeface="Calibri" pitchFamily="34" charset="-120"/>
                         </a:rPr>
-                        <a:t>TA - Parada Programada</a:t>
+                        <a:t>EIM - Manutenção &amp; Integridade</a:t>
                       </a:r>
                       <a:endParaRPr lang="en-US" sz="900" dirty="0">
                         <a:latin typeface="Calibri" charset="0"/>
@@ -25861,7 +25861,7 @@
                           <a:ea typeface="Calibri" pitchFamily="34" charset="-122"/>
                           <a:cs typeface="Calibri" pitchFamily="34" charset="-120"/>
                         </a:rPr>
-                        <a:t>Eficiência de Produção</a:t>
+                        <a:t>Rotina Operacional</a:t>
                       </a:r>
                       <a:endParaRPr lang="en-US" sz="900" dirty="0">
                         <a:latin typeface="Calibri" charset="0"/>
@@ -25929,7 +25929,7 @@
                           <a:ea typeface="Calibri" pitchFamily="34" charset="-122"/>
                           <a:cs typeface="Calibri" pitchFamily="34" charset="-120"/>
                         </a:rPr>
-                        <a:t>US$ 659,4 mil</a:t>
+                        <a:t>US$ 414,5 mil</a:t>
                       </a:r>
                       <a:endParaRPr lang="en-US" sz="1000" dirty="0">
                         <a:latin typeface="Calibri" charset="0"/>
@@ -26067,7 +26067,7 @@
                           <a:ea typeface="Calibri" pitchFamily="34" charset="-122"/>
                           <a:cs typeface="Calibri" pitchFamily="34" charset="-120"/>
                         </a:rPr>
-                        <a:t>Revitalização do compressor de Ar de Instrumento</a:t>
+                        <a:t>Novas Destiladoras</a:t>
                       </a:r>
                       <a:endParaRPr lang="en-US" sz="1000" dirty="0">
                         <a:latin typeface="Calibri" charset="0"/>
@@ -26135,7 +26135,7 @@
                           <a:ea typeface="Calibri" pitchFamily="34" charset="-122"/>
                           <a:cs typeface="Calibri" pitchFamily="34" charset="-120"/>
                         </a:rPr>
-                        <a:t>Polvo A</a:t>
+                        <a:t>FPSO Bravo</a:t>
                       </a:r>
                       <a:endParaRPr lang="en-US" sz="950" dirty="0">
                         <a:latin typeface="Calibri" charset="0"/>
@@ -26339,7 +26339,7 @@
                           <a:ea typeface="Calibri" pitchFamily="34" charset="-122"/>
                           <a:cs typeface="Calibri" pitchFamily="34" charset="-120"/>
                         </a:rPr>
-                        <a:t>US$ 544,8 mil</a:t>
+                        <a:t>US$ 411,9 mil</a:t>
                       </a:r>
                       <a:endParaRPr lang="en-US" sz="1000" dirty="0">
                         <a:latin typeface="Calibri" charset="0"/>
@@ -26477,7 +26477,7 @@
                           <a:ea typeface="Calibri" pitchFamily="34" charset="-122"/>
                           <a:cs typeface="Calibri" pitchFamily="34" charset="-120"/>
                         </a:rPr>
-                        <a:t>TA - Compra de Placas de controle dos VFDs Rockwell</a:t>
+                        <a:t>Instalação de Sensores de Hidrogênio nas Salas de Baterias</a:t>
                       </a:r>
                       <a:endParaRPr lang="en-US" sz="1000" dirty="0">
                         <a:latin typeface="Calibri" charset="0"/>
@@ -26545,7 +26545,7 @@
                           <a:ea typeface="Calibri" pitchFamily="34" charset="-122"/>
                           <a:cs typeface="Calibri" pitchFamily="34" charset="-120"/>
                         </a:rPr>
-                        <a:t>Polvo A</a:t>
+                        <a:t>FPSO Bravo</a:t>
                       </a:r>
                       <a:endParaRPr lang="en-US" sz="950" dirty="0">
                         <a:latin typeface="Calibri" charset="0"/>
@@ -26613,7 +26613,7 @@
                           <a:ea typeface="Calibri" pitchFamily="34" charset="-122"/>
                           <a:cs typeface="Calibri" pitchFamily="34" charset="-120"/>
                         </a:rPr>
-                        <a:t>EIM - Manutenção &amp; Integridade</a:t>
+                        <a:t>Projetos</a:t>
                       </a:r>
                       <a:endParaRPr lang="en-US" sz="900" dirty="0">
                         <a:latin typeface="Calibri" charset="0"/>
@@ -26681,7 +26681,7 @@
                           <a:ea typeface="Calibri" pitchFamily="34" charset="-122"/>
                           <a:cs typeface="Calibri" pitchFamily="34" charset="-120"/>
                         </a:rPr>
-                        <a:t>Rotina Operacional</a:t>
+                        <a:t>Integridade e Regulatório</a:t>
                       </a:r>
                       <a:endParaRPr lang="en-US" sz="900" dirty="0">
                         <a:latin typeface="Calibri" charset="0"/>
@@ -26749,7 +26749,7 @@
                           <a:ea typeface="Calibri" pitchFamily="34" charset="-122"/>
                           <a:cs typeface="Calibri" pitchFamily="34" charset="-120"/>
                         </a:rPr>
-                        <a:t>US$ 526,1 mil</a:t>
+                        <a:t>US$ 281,8 mil</a:t>
                       </a:r>
                       <a:endParaRPr lang="en-US" sz="1000" dirty="0">
                         <a:latin typeface="Calibri" charset="0"/>
@@ -26838,7 +26838,7 @@
                 <a:ea typeface="Calibri" pitchFamily="34" charset="-122"/>
                 <a:cs typeface="Calibri" pitchFamily="34" charset="-120"/>
               </a:rPr>
-              <a:t>Metodologia: Cost Allocation = CAPEX, status 'Contar'/'TA', excl. Desenvolvimento de Produção. Soma do top 10: US$ 12,8 mi (58,4% do CAPEX do grupo).</a:t>
+              <a:t>Metodologia: Cost Allocation = CAPEX, status 'Contar'/'TA', restrito às áreas priorizadas acima, excl. Desenvolvimento de Produção. Soma do top 10: US$ 9,5 mi (87,2% do CAPEX nessas áreas).</a:t>
             </a:r>
             <a:endParaRPr lang="en-US" sz="850" dirty="0"/>
           </a:p>
@@ -28875,7 +28875,7 @@
                 <a:ea typeface="Calibri" pitchFamily="34" charset="-122"/>
                 <a:cs typeface="Calibri" pitchFamily="34" charset="-120"/>
               </a:rPr>
-              <a:t>Ano 2027 · maiores escopos individuais de CAPEX (status 'Contar' + 'TA') · CAPEX total do grupo: US$ 47,0 mi</a:t>
+              <a:t>Ano 2027 · maiores escopos de CAPEX nas áreas priorizadas (Manutenção, Suporte Técnico, Confiabilidade, Integridade, Naval, Construção, Projetos) · total nessas áreas: US$ 27,6 mi</a:t>
             </a:r>
             <a:endParaRPr lang="en-US" sz="1250" dirty="0"/>
           </a:p>
@@ -30227,7 +30227,7 @@
                           <a:ea typeface="Calibri" pitchFamily="34" charset="-122"/>
                           <a:cs typeface="Calibri" pitchFamily="34" charset="-120"/>
                         </a:rPr>
-                        <a:t>Substituição de Internos do Coalescer (TAR)</a:t>
+                        <a:t>Upgrade de obsolescência do INSUM</a:t>
                       </a:r>
                       <a:endParaRPr lang="en-US" sz="1000" dirty="0">
                         <a:latin typeface="Calibri" charset="0"/>
@@ -30295,7 +30295,7 @@
                           <a:ea typeface="Calibri" pitchFamily="34" charset="-122"/>
                           <a:cs typeface="Calibri" pitchFamily="34" charset="-120"/>
                         </a:rPr>
-                        <a:t>FPSO Peregrino</a:t>
+                        <a:t>PLAT B</a:t>
                       </a:r>
                       <a:endParaRPr lang="en-US" sz="950" dirty="0">
                         <a:latin typeface="Calibri" charset="0"/>
@@ -30363,7 +30363,7 @@
                           <a:ea typeface="Calibri" pitchFamily="34" charset="-122"/>
                           <a:cs typeface="Calibri" pitchFamily="34" charset="-120"/>
                         </a:rPr>
-                        <a:t>P&amp;Q - Processos</a:t>
+                        <a:t>Suporte Técnico</a:t>
                       </a:r>
                       <a:endParaRPr lang="en-US" sz="900" dirty="0">
                         <a:latin typeface="Calibri" charset="0"/>
@@ -30431,7 +30431,7 @@
                           <a:ea typeface="Calibri" pitchFamily="34" charset="-122"/>
                           <a:cs typeface="Calibri" pitchFamily="34" charset="-120"/>
                         </a:rPr>
-                        <a:t>Eficiência de Produção</a:t>
+                        <a:t>Integridade e Regulatório</a:t>
                       </a:r>
                       <a:endParaRPr lang="en-US" sz="900" dirty="0">
                         <a:latin typeface="Calibri" charset="0"/>
@@ -30705,7 +30705,7 @@
                           <a:ea typeface="Calibri" pitchFamily="34" charset="-122"/>
                           <a:cs typeface="Calibri" pitchFamily="34" charset="-120"/>
                         </a:rPr>
-                        <a:t>PLAT B</a:t>
+                        <a:t>PLAT A</a:t>
                       </a:r>
                       <a:endParaRPr lang="en-US" sz="950" dirty="0">
                         <a:latin typeface="Calibri" charset="0"/>
@@ -31047,7 +31047,7 @@
                           <a:ea typeface="Calibri" pitchFamily="34" charset="-122"/>
                           <a:cs typeface="Calibri" pitchFamily="34" charset="-120"/>
                         </a:rPr>
-                        <a:t>Upgrade de obsolescência do INSUM</a:t>
+                        <a:t>Troca da Membrana do Sistema de Geração de Nitrogênio Alpha e Bravo</a:t>
                       </a:r>
                       <a:endParaRPr lang="en-US" sz="1000" dirty="0">
                         <a:latin typeface="Calibri" charset="0"/>
@@ -31115,7 +31115,7 @@
                           <a:ea typeface="Calibri" pitchFamily="34" charset="-122"/>
                           <a:cs typeface="Calibri" pitchFamily="34" charset="-120"/>
                         </a:rPr>
-                        <a:t>PLAT A</a:t>
+                        <a:t>FPSO Peregrino</a:t>
                       </a:r>
                       <a:endParaRPr lang="en-US" sz="950" dirty="0">
                         <a:latin typeface="Calibri" charset="0"/>
@@ -31183,7 +31183,7 @@
                           <a:ea typeface="Calibri" pitchFamily="34" charset="-122"/>
                           <a:cs typeface="Calibri" pitchFamily="34" charset="-120"/>
                         </a:rPr>
-                        <a:t>Suporte Técnico</a:t>
+                        <a:t>Grandes Manutenções</a:t>
                       </a:r>
                       <a:endParaRPr lang="en-US" sz="900" dirty="0">
                         <a:latin typeface="Calibri" charset="0"/>
@@ -31251,7 +31251,7 @@
                           <a:ea typeface="Calibri" pitchFamily="34" charset="-122"/>
                           <a:cs typeface="Calibri" pitchFamily="34" charset="-120"/>
                         </a:rPr>
-                        <a:t>Integridade e Regulatório</a:t>
+                        <a:t>Eficiência de Produção</a:t>
                       </a:r>
                       <a:endParaRPr lang="en-US" sz="900" dirty="0">
                         <a:latin typeface="Calibri" charset="0"/>
@@ -31319,7 +31319,7 @@
                           <a:ea typeface="Calibri" pitchFamily="34" charset="-122"/>
                           <a:cs typeface="Calibri" pitchFamily="34" charset="-120"/>
                         </a:rPr>
-                        <a:t>US$ 2,0 mi</a:t>
+                        <a:t>US$ 1,3 mi</a:t>
                       </a:r>
                       <a:endParaRPr lang="en-US" sz="1000" dirty="0">
                         <a:latin typeface="Calibri" charset="0"/>
@@ -31457,7 +31457,7 @@
                           <a:ea typeface="Calibri" pitchFamily="34" charset="-122"/>
                           <a:cs typeface="Calibri" pitchFamily="34" charset="-120"/>
                         </a:rPr>
-                        <a:t>Troca da Membrana do Sistema de Geração de Nitrogênio Alpha e Bravo</a:t>
+                        <a:t>Overhaul da Bomba Framo (SWLP) - B</a:t>
                       </a:r>
                       <a:endParaRPr lang="en-US" sz="1000" dirty="0">
                         <a:latin typeface="Calibri" charset="0"/>
@@ -31593,7 +31593,7 @@
                           <a:ea typeface="Calibri" pitchFamily="34" charset="-122"/>
                           <a:cs typeface="Calibri" pitchFamily="34" charset="-120"/>
                         </a:rPr>
-                        <a:t>Grandes Manutenções</a:t>
+                        <a:t>MNT – Manutenção</a:t>
                       </a:r>
                       <a:endParaRPr lang="en-US" sz="900" dirty="0">
                         <a:latin typeface="Calibri" charset="0"/>
@@ -31661,7 +31661,7 @@
                           <a:ea typeface="Calibri" pitchFamily="34" charset="-122"/>
                           <a:cs typeface="Calibri" pitchFamily="34" charset="-120"/>
                         </a:rPr>
-                        <a:t>Eficiência de Produção</a:t>
+                        <a:t>Rotina Operacional</a:t>
                       </a:r>
                       <a:endParaRPr lang="en-US" sz="900" dirty="0">
                         <a:latin typeface="Calibri" charset="0"/>
@@ -31867,7 +31867,7 @@
                           <a:ea typeface="Calibri" pitchFamily="34" charset="-122"/>
                           <a:cs typeface="Calibri" pitchFamily="34" charset="-120"/>
                         </a:rPr>
-                        <a:t>Overhaul da Bomba Framo (SWLP) - B</a:t>
+                        <a:t>Caldeira B</a:t>
                       </a:r>
                       <a:endParaRPr lang="en-US" sz="1000" dirty="0">
                         <a:latin typeface="Calibri" charset="0"/>
@@ -32003,7 +32003,7 @@
                           <a:ea typeface="Calibri" pitchFamily="34" charset="-122"/>
                           <a:cs typeface="Calibri" pitchFamily="34" charset="-120"/>
                         </a:rPr>
-                        <a:t>MNT – Manutenção</a:t>
+                        <a:t>CON - Construção</a:t>
                       </a:r>
                       <a:endParaRPr lang="en-US" sz="900" dirty="0">
                         <a:latin typeface="Calibri" charset="0"/>
@@ -32071,7 +32071,7 @@
                           <a:ea typeface="Calibri" pitchFamily="34" charset="-122"/>
                           <a:cs typeface="Calibri" pitchFamily="34" charset="-120"/>
                         </a:rPr>
-                        <a:t>Rotina Operacional</a:t>
+                        <a:t>Integridade e Regulatório</a:t>
                       </a:r>
                       <a:endParaRPr lang="en-US" sz="900" dirty="0">
                         <a:latin typeface="Calibri" charset="0"/>
@@ -32139,7 +32139,7 @@
                           <a:ea typeface="Calibri" pitchFamily="34" charset="-122"/>
                           <a:cs typeface="Calibri" pitchFamily="34" charset="-120"/>
                         </a:rPr>
-                        <a:t>US$ 1,3 mi</a:t>
+                        <a:t>US$ 1,0 mi</a:t>
                       </a:r>
                       <a:endParaRPr lang="en-US" sz="1000" dirty="0">
                         <a:latin typeface="Calibri" charset="0"/>
@@ -32277,7 +32277,7 @@
                           <a:ea typeface="Calibri" pitchFamily="34" charset="-122"/>
                           <a:cs typeface="Calibri" pitchFamily="34" charset="-120"/>
                         </a:rPr>
-                        <a:t>Desmobilização - TA</a:t>
+                        <a:t>Instalação Novo Header de Vapor</a:t>
                       </a:r>
                       <a:endParaRPr lang="en-US" sz="1000" dirty="0">
                         <a:latin typeface="Calibri" charset="0"/>
@@ -32413,7 +32413,7 @@
                           <a:ea typeface="Calibri" pitchFamily="34" charset="-122"/>
                           <a:cs typeface="Calibri" pitchFamily="34" charset="-120"/>
                         </a:rPr>
-                        <a:t>TA - Parada Programada</a:t>
+                        <a:t>Projetos</a:t>
                       </a:r>
                       <a:endParaRPr lang="en-US" sz="900" dirty="0">
                         <a:latin typeface="Calibri" charset="0"/>
@@ -32549,7 +32549,7 @@
                           <a:ea typeface="Calibri" pitchFamily="34" charset="-122"/>
                           <a:cs typeface="Calibri" pitchFamily="34" charset="-120"/>
                         </a:rPr>
-                        <a:t>US$ 1,0 mi</a:t>
+                        <a:t>US$ 882,9 mil</a:t>
                       </a:r>
                       <a:endParaRPr lang="en-US" sz="1000" dirty="0">
                         <a:latin typeface="Calibri" charset="0"/>
@@ -32687,7 +32687,7 @@
                           <a:ea typeface="Calibri" pitchFamily="34" charset="-122"/>
                           <a:cs typeface="Calibri" pitchFamily="34" charset="-120"/>
                         </a:rPr>
-                        <a:t>Mobilização - TA</a:t>
+                        <a:t>Overhaul da STG-B e Gerador Elétrico</a:t>
                       </a:r>
                       <a:endParaRPr lang="en-US" sz="1000" dirty="0">
                         <a:latin typeface="Calibri" charset="0"/>
@@ -32823,7 +32823,7 @@
                           <a:ea typeface="Calibri" pitchFamily="34" charset="-122"/>
                           <a:cs typeface="Calibri" pitchFamily="34" charset="-120"/>
                         </a:rPr>
-                        <a:t>TA - Parada Programada</a:t>
+                        <a:t>MNT – Manutenção</a:t>
                       </a:r>
                       <a:endParaRPr lang="en-US" sz="900" dirty="0">
                         <a:latin typeface="Calibri" charset="0"/>
@@ -32891,7 +32891,7 @@
                           <a:ea typeface="Calibri" pitchFamily="34" charset="-122"/>
                           <a:cs typeface="Calibri" pitchFamily="34" charset="-120"/>
                         </a:rPr>
-                        <a:t>Eficiência de Produção</a:t>
+                        <a:t>Rotina Operacional</a:t>
                       </a:r>
                       <a:endParaRPr lang="en-US" sz="900" dirty="0">
                         <a:latin typeface="Calibri" charset="0"/>
@@ -32959,7 +32959,7 @@
                           <a:ea typeface="Calibri" pitchFamily="34" charset="-122"/>
                           <a:cs typeface="Calibri" pitchFamily="34" charset="-120"/>
                         </a:rPr>
-                        <a:t>US$ 1,0 mi</a:t>
+                        <a:t>US$ 698,8 mil</a:t>
                       </a:r>
                       <a:endParaRPr lang="en-US" sz="1000" dirty="0">
                         <a:latin typeface="Calibri" charset="0"/>
@@ -33097,7 +33097,7 @@
                           <a:ea typeface="Calibri" pitchFamily="34" charset="-122"/>
                           <a:cs typeface="Calibri" pitchFamily="34" charset="-120"/>
                         </a:rPr>
-                        <a:t>Caldeira B</a:t>
+                        <a:t>Upgrade do Sistema Meteoceanográfico</a:t>
                       </a:r>
                       <a:endParaRPr lang="en-US" sz="1000" dirty="0">
                         <a:latin typeface="Calibri" charset="0"/>
@@ -33233,7 +33233,7 @@
                           <a:ea typeface="Calibri" pitchFamily="34" charset="-122"/>
                           <a:cs typeface="Calibri" pitchFamily="34" charset="-120"/>
                         </a:rPr>
-                        <a:t>CON - Construção</a:t>
+                        <a:t>Projetos</a:t>
                       </a:r>
                       <a:endParaRPr lang="en-US" sz="900" dirty="0">
                         <a:latin typeface="Calibri" charset="0"/>
@@ -33301,7 +33301,7 @@
                           <a:ea typeface="Calibri" pitchFamily="34" charset="-122"/>
                           <a:cs typeface="Calibri" pitchFamily="34" charset="-120"/>
                         </a:rPr>
-                        <a:t>Integridade e Regulatório</a:t>
+                        <a:t>Eficiência de Produção</a:t>
                       </a:r>
                       <a:endParaRPr lang="en-US" sz="900" dirty="0">
                         <a:latin typeface="Calibri" charset="0"/>
@@ -33369,7 +33369,7 @@
                           <a:ea typeface="Calibri" pitchFamily="34" charset="-122"/>
                           <a:cs typeface="Calibri" pitchFamily="34" charset="-120"/>
                         </a:rPr>
-                        <a:t>US$ 1,0 mi</a:t>
+                        <a:t>US$ 634,7 mil</a:t>
                       </a:r>
                       <a:endParaRPr lang="en-US" sz="1000" dirty="0">
                         <a:latin typeface="Calibri" charset="0"/>
@@ -33458,7 +33458,7 @@
                 <a:ea typeface="Calibri" pitchFamily="34" charset="-122"/>
                 <a:cs typeface="Calibri" pitchFamily="34" charset="-120"/>
               </a:rPr>
-              <a:t>Metodologia: Cost Allocation = CAPEX, status 'Contar'/'TA', excl. Desenvolvimento de Produção. Soma do top 10: US$ 18,3 mi (39,0% do CAPEX do grupo).</a:t>
+              <a:t>Metodologia: Cost Allocation = CAPEX, status 'Contar'/'TA', restrito às áreas priorizadas acima, excl. Desenvolvimento de Produção. Soma do top 10: US$ 16,5 mi (59,8% do CAPEX nessas áreas).</a:t>
             </a:r>
             <a:endParaRPr lang="en-US" sz="850" dirty="0"/>
           </a:p>

</xml_diff>

<commit_message>
Remove Baixa de Material Mecânico/Elétrica from Top 5 OPEX panels too
Same correction applied to the Gantt deck: these two items are
excluded from the Top 5 OPEX por Ativo ranking (FPSO Bravo and Polvo A
were the only assets affected), backfilled with the next-highest
scopes so each panel still shows 5 items.
</commit_message>
<xml_diff>
--- a/PRIO_Top_CAPEX_OPEX_Despriorizados_2027.pptx
+++ b/PRIO_Top_CAPEX_OPEX_Despriorizados_2027.pptx
@@ -27305,7 +27305,7 @@
                           <a:ea typeface="Calibri" pitchFamily="34" charset="-122"/>
                           <a:cs typeface="Calibri" pitchFamily="34" charset="-120"/>
                         </a:rPr>
-                        <a:t>Baixa de Material Mecânico</a:t>
+                        <a:t>Mergulho - Tamponamento da caixa de mar</a:t>
                       </a:r>
                       <a:endParaRPr lang="en-US" sz="1000" dirty="0">
                         <a:latin typeface="Calibri" charset="0"/>
@@ -27373,7 +27373,7 @@
                           <a:ea typeface="Calibri" pitchFamily="34" charset="-122"/>
                           <a:cs typeface="Calibri" pitchFamily="34" charset="-120"/>
                         </a:rPr>
-                        <a:t>US$ 1,3 mi</a:t>
+                        <a:t>US$ 1,2 mi</a:t>
                       </a:r>
                       <a:endParaRPr lang="en-US" sz="1000" dirty="0">
                         <a:latin typeface="Calibri" charset="0"/>
@@ -27443,7 +27443,7 @@
                           <a:ea typeface="Calibri" pitchFamily="34" charset="-122"/>
                           <a:cs typeface="Calibri" pitchFamily="34" charset="-120"/>
                         </a:rPr>
-                        <a:t>Mergulho - Tamponamento da caixa de mar</a:t>
+                        <a:t>M5 - Time de Construção - Instalações (Fabric, Constr e Mont.)</a:t>
                       </a:r>
                       <a:endParaRPr lang="en-US" sz="1000" dirty="0">
                         <a:latin typeface="Calibri" charset="0"/>
@@ -27511,7 +27511,7 @@
                           <a:ea typeface="Calibri" pitchFamily="34" charset="-122"/>
                           <a:cs typeface="Calibri" pitchFamily="34" charset="-120"/>
                         </a:rPr>
-                        <a:t>US$ 1,2 mi</a:t>
+                        <a:t>US$ 1,1 mi</a:t>
                       </a:r>
                       <a:endParaRPr lang="en-US" sz="1000" dirty="0">
                         <a:latin typeface="Calibri" charset="0"/>
@@ -27581,7 +27581,7 @@
                           <a:ea typeface="Calibri" pitchFamily="34" charset="-122"/>
                           <a:cs typeface="Calibri" pitchFamily="34" charset="-120"/>
                         </a:rPr>
-                        <a:t>M5 - Time de Construção - Instalações (Fabric, Constr e Mont.)</a:t>
+                        <a:t>Sistema de Dilúvio (FW e FF) - Troca de Tubulações</a:t>
                       </a:r>
                       <a:endParaRPr lang="en-US" sz="1000" dirty="0">
                         <a:latin typeface="Calibri" charset="0"/>
@@ -27719,7 +27719,7 @@
                           <a:ea typeface="Calibri" pitchFamily="34" charset="-122"/>
                           <a:cs typeface="Calibri" pitchFamily="34" charset="-120"/>
                         </a:rPr>
-                        <a:t>Sistema de Dilúvio (FW e FF) - Troca de Tubulações</a:t>
+                        <a:t>Inspeção de Sistema de Tubulação - 13 Sistemas</a:t>
                       </a:r>
                       <a:endParaRPr lang="en-US" sz="1000" dirty="0">
                         <a:latin typeface="Calibri" charset="0"/>
@@ -27787,7 +27787,7 @@
                           <a:ea typeface="Calibri" pitchFamily="34" charset="-122"/>
                           <a:cs typeface="Calibri" pitchFamily="34" charset="-120"/>
                         </a:rPr>
-                        <a:t>US$ 1,1 mi</a:t>
+                        <a:t>US$ 964,4 mil</a:t>
                       </a:r>
                       <a:endParaRPr lang="en-US" sz="1000" dirty="0">
                         <a:latin typeface="Calibri" charset="0"/>
@@ -27926,7 +27926,7 @@
                           <a:ea typeface="Calibri" pitchFamily="34" charset="-122"/>
                           <a:cs typeface="Calibri" pitchFamily="34" charset="-120"/>
                         </a:rPr>
-                        <a:t>Baixa de Material Mecânico</a:t>
+                        <a:t>Baixa de material Automação</a:t>
                       </a:r>
                       <a:endParaRPr lang="en-US" sz="1000" dirty="0">
                         <a:latin typeface="Calibri" charset="0"/>
@@ -27994,7 +27994,7 @@
                           <a:ea typeface="Calibri" pitchFamily="34" charset="-122"/>
                           <a:cs typeface="Calibri" pitchFamily="34" charset="-120"/>
                         </a:rPr>
-                        <a:t>US$ 960,0 mil</a:t>
+                        <a:t>US$ 628,8 mil</a:t>
                       </a:r>
                       <a:endParaRPr lang="en-US" sz="1000" dirty="0">
                         <a:latin typeface="Calibri" charset="0"/>
@@ -28064,7 +28064,7 @@
                           <a:ea typeface="Calibri" pitchFamily="34" charset="-122"/>
                           <a:cs typeface="Calibri" pitchFamily="34" charset="-120"/>
                         </a:rPr>
-                        <a:t>Baixa de material Automação</a:t>
+                        <a:t>M5 - Time de Construção - Instalações (Fabric, Constr e Mont.)</a:t>
                       </a:r>
                       <a:endParaRPr lang="en-US" sz="1000" dirty="0">
                         <a:latin typeface="Calibri" charset="0"/>
@@ -28132,7 +28132,7 @@
                           <a:ea typeface="Calibri" pitchFamily="34" charset="-122"/>
                           <a:cs typeface="Calibri" pitchFamily="34" charset="-120"/>
                         </a:rPr>
-                        <a:t>US$ 628,8 mil</a:t>
+                        <a:t>US$ 610,0 mil</a:t>
                       </a:r>
                       <a:endParaRPr lang="en-US" sz="1000" dirty="0">
                         <a:latin typeface="Calibri" charset="0"/>
@@ -28202,7 +28202,7 @@
                           <a:ea typeface="Calibri" pitchFamily="34" charset="-122"/>
                           <a:cs typeface="Calibri" pitchFamily="34" charset="-120"/>
                         </a:rPr>
-                        <a:t>M5 - Time de Construção - Instalações (Fabric, Constr e Mont.)</a:t>
+                        <a:t>Apoio à Manutenção - Time de Construção - Instalações</a:t>
                       </a:r>
                       <a:endParaRPr lang="en-US" sz="1000" dirty="0">
                         <a:latin typeface="Calibri" charset="0"/>
@@ -28270,7 +28270,7 @@
                           <a:ea typeface="Calibri" pitchFamily="34" charset="-122"/>
                           <a:cs typeface="Calibri" pitchFamily="34" charset="-120"/>
                         </a:rPr>
-                        <a:t>US$ 610,0 mil</a:t>
+                        <a:t>US$ 600,0 mil</a:t>
                       </a:r>
                       <a:endParaRPr lang="en-US" sz="1000" dirty="0">
                         <a:latin typeface="Calibri" charset="0"/>
@@ -28340,7 +28340,7 @@
                           <a:ea typeface="Calibri" pitchFamily="34" charset="-122"/>
                           <a:cs typeface="Calibri" pitchFamily="34" charset="-120"/>
                         </a:rPr>
-                        <a:t>Apoio à Manutenção - Time de Construção - Instalações</a:t>
+                        <a:t>Campanha de normatização de DTPs - WHP Polvo-A</a:t>
                       </a:r>
                       <a:endParaRPr lang="en-US" sz="1000" dirty="0">
                         <a:latin typeface="Calibri" charset="0"/>
@@ -28408,7 +28408,7 @@
                           <a:ea typeface="Calibri" pitchFamily="34" charset="-122"/>
                           <a:cs typeface="Calibri" pitchFamily="34" charset="-120"/>
                         </a:rPr>
-                        <a:t>US$ 600,0 mil</a:t>
+                        <a:t>US$ 419,8 mil</a:t>
                       </a:r>
                       <a:endParaRPr lang="en-US" sz="1000" dirty="0">
                         <a:latin typeface="Calibri" charset="0"/>
@@ -28478,7 +28478,7 @@
                           <a:ea typeface="Calibri" pitchFamily="34" charset="-122"/>
                           <a:cs typeface="Calibri" pitchFamily="34" charset="-120"/>
                         </a:rPr>
-                        <a:t>Campanha de normatização de DTPs - WHP Polvo-A</a:t>
+                        <a:t>INSPEÇÃO QUINQUENAL DE GUINDASTE NORTE</a:t>
                       </a:r>
                       <a:endParaRPr lang="en-US" sz="1000" dirty="0">
                         <a:latin typeface="Calibri" charset="0"/>
@@ -28546,7 +28546,7 @@
                           <a:ea typeface="Calibri" pitchFamily="34" charset="-122"/>
                           <a:cs typeface="Calibri" pitchFamily="34" charset="-120"/>
                         </a:rPr>
-                        <a:t>US$ 419,8 mil</a:t>
+                        <a:t>US$ 372,5 mil</a:t>
                       </a:r>
                       <a:endParaRPr lang="en-US" sz="1000" dirty="0">
                         <a:latin typeface="Calibri" charset="0"/>

</xml_diff>